<commit_message>
HW1: add group member names and AI-use statement to write-up and slides
Co-Authored-By: Claude Opus 5.5 <noreply@anthropic.com>
</commit_message>
<xml_diff>
--- a/hw1/report/MGT634_HW1_NHAMCS_slides.pptx
+++ b/hw1/report/MGT634_HW1_NHAMCS_slides.pptx
@@ -5704,7 +5704,7 @@
                 </a:solidFill>
                 <a:latin typeface="Calibri"/>
               </a:rPr>
-              <a:t>Group: Michal Kozuchowski, [add teammate names]</a:t>
+              <a:t>Group: Michal Kozuchowski, Laila Lapins, Nick Giamalis, Raymond Chang, Sean Weller</a:t>
             </a:r>
           </a:p>
         </p:txBody>
@@ -8316,6 +8316,45 @@
                 <a:latin typeface="Calibri"/>
               </a:rPr>
               <a:t>Staff to the plateau and Mondays  ·  Fast-track levels 4-5 so emergent patients stop waiting as long as nonurgent ones  ·  Protect margins through Medicaid contracting and payer capture  ·  Invest in chronic-care coordination</a:t>
+            </a:r>
+          </a:p>
+        </p:txBody>
+      </p:sp>
+      <p:sp>
+        <p:nvSpPr>
+          <p:cNvPr id="10" name="TextBox 9"/>
+          <p:cNvSpPr txBox="1"/>
+          <p:nvPr/>
+        </p:nvSpPr>
+        <p:spPr>
+          <a:xfrm>
+            <a:off x="548640" y="6263640"/>
+            <a:ext cx="11064240" cy="320040"/>
+          </a:xfrm>
+          <a:prstGeom prst="rect">
+            <a:avLst/>
+          </a:prstGeom>
+          <a:noFill/>
+        </p:spPr>
+        <p:txBody>
+          <a:bodyPr wrap="square" anchor="t" lIns="0" rIns="0" tIns="0" bIns="0">
+            <a:spAutoFit/>
+          </a:bodyPr>
+          <a:lstStyle/>
+          <a:p>
+            <a:pPr algn="l">
+              <a:spcAft>
+                <a:spcPts val="600"/>
+              </a:spcAft>
+            </a:pPr>
+            <a:r>
+              <a:rPr sz="1000" b="0" i="0">
+                <a:solidFill>
+                  <a:srgbClr val="CADCFC"/>
+                </a:solidFill>
+                <a:latin typeface="Calibri"/>
+              </a:rPr>
+              <a:t>AI use (required by the course): code written with Claude via Claude Code, directed by the group; every result run on the Yale cluster and checked against NCHS figures (20/20); slides drafted with AI from verified outputs.</a:t>
             </a:r>
           </a:p>
         </p:txBody>

</xml_diff>

<commit_message>
HW1: revise write-up and slides after review
- Describe checks accurately: NCHS comparisons (Table 1, wait-time missingness
  15.2% vs 15.7% published) are separate from the 20-value reproducibility check
- Payer = primary expected payer, not revenue; conditional financial discussion
- Qualify intent, chronic-condition and missingness claims; triage comparisons
  descriptive only; rare deaths below NCHS 30-record threshold not broken out
- Chronic chart shows combined diabetes to match the text; layout rebalanced
- Slides refocused per review; no 20/20 card or ED-death figure

Co-Authored-By: Claude Opus 5.5 <noreply@anthropic.com>
</commit_message>
<xml_diff>
--- a/hw1/report/MGT634_HW1_NHAMCS_slides.pptx
+++ b/hw1/report/MGT634_HW1_NHAMCS_slides.pptx
@@ -162,25 +162,11 @@
                         </a:solidFill>
                         <a:latin typeface="Calibri"/>
                       </a:rPr>
-                      <a:t>6pm peak: 6.3%</a:t>
+                      <a:t>6pm: 6.3%</a:t>
                     </a:r>
                   </a:p>
                 </c:rich>
               </c:tx>
-              <c:txPr>
-                <a:bodyPr/>
-                <a:lstStyle/>
-                <a:p>
-                  <a:pPr>
-                    <a:defRPr sz="1100" b="1">
-                      <a:solidFill>
-                        <a:srgbClr val="EB6834"/>
-                      </a:solidFill>
-                      <a:latin typeface="Calibri"/>
-                    </a:defRPr>
-                  </a:pPr>
-                </a:p>
-              </c:txPr>
               <c:dLblPos val="outEnd"/>
               <c:showLegendKey val="0"/>
               <c:showVal val="1"/>
@@ -377,7 +363,12 @@
               <a:lstStyle/>
               <a:p>
                 <a:r>
-                  <a:rPr sz="1100"/>
+                  <a:rPr sz="1100" b="0">
+                    <a:solidFill>
+                      <a:srgbClr val="5A5F66"/>
+                    </a:solidFill>
+                    <a:latin typeface="Calibri"/>
+                  </a:rPr>
                   <a:t>Arrival hour (0 = midnight)</a:t>
                 </a:r>
               </a:p>
@@ -460,7 +451,7 @@
 <c:chartSpace xmlns:c="http://schemas.openxmlformats.org/drawingml/2006/chart" xmlns:a="http://schemas.openxmlformats.org/drawingml/2006/main" xmlns:r="http://schemas.openxmlformats.org/officeDocument/2006/relationships">
   <c:date1904 val="0"/>
   <c:chart>
-    <c:autoTitleDeleted val="0"/>
+    <c:autoTitleDeleted val="1"/>
     <c:plotArea>
       <c:barChart>
         <c:barDir val="bar"/>
@@ -509,20 +500,6 @@
                   </a:p>
                 </c:rich>
               </c:tx>
-              <c:txPr>
-                <a:bodyPr/>
-                <a:lstStyle/>
-                <a:p>
-                  <a:pPr>
-                    <a:defRPr sz="1000" b="1">
-                      <a:solidFill>
-                        <a:srgbClr val="FFFFFF"/>
-                      </a:solidFill>
-                      <a:latin typeface="Calibri"/>
-                    </a:defRPr>
-                  </a:pPr>
-                </a:p>
-              </c:txPr>
               <c:dLblPos val="ctr"/>
               <c:showLegendKey val="0"/>
               <c:showVal val="1"/>
@@ -550,20 +527,6 @@
                   </a:p>
                 </c:rich>
               </c:tx>
-              <c:txPr>
-                <a:bodyPr/>
-                <a:lstStyle/>
-                <a:p>
-                  <a:pPr>
-                    <a:defRPr sz="1000" b="1">
-                      <a:solidFill>
-                        <a:srgbClr val="FFFFFF"/>
-                      </a:solidFill>
-                      <a:latin typeface="Calibri"/>
-                    </a:defRPr>
-                  </a:pPr>
-                </a:p>
-              </c:txPr>
               <c:dLblPos val="ctr"/>
               <c:showLegendKey val="0"/>
               <c:showVal val="1"/>
@@ -591,20 +554,6 @@
                   </a:p>
                 </c:rich>
               </c:tx>
-              <c:txPr>
-                <a:bodyPr/>
-                <a:lstStyle/>
-                <a:p>
-                  <a:pPr>
-                    <a:defRPr sz="1000" b="1">
-                      <a:solidFill>
-                        <a:srgbClr val="FFFFFF"/>
-                      </a:solidFill>
-                      <a:latin typeface="Calibri"/>
-                    </a:defRPr>
-                  </a:pPr>
-                </a:p>
-              </c:txPr>
               <c:dLblPos val="ctr"/>
               <c:showLegendKey val="0"/>
               <c:showVal val="1"/>
@@ -632,20 +581,6 @@
                   </a:p>
                 </c:rich>
               </c:tx>
-              <c:txPr>
-                <a:bodyPr/>
-                <a:lstStyle/>
-                <a:p>
-                  <a:pPr>
-                    <a:defRPr sz="1000" b="1">
-                      <a:solidFill>
-                        <a:srgbClr val="FFFFFF"/>
-                      </a:solidFill>
-                      <a:latin typeface="Calibri"/>
-                    </a:defRPr>
-                  </a:pPr>
-                </a:p>
-              </c:txPr>
               <c:dLblPos val="ctr"/>
               <c:showLegendKey val="0"/>
               <c:showVal val="1"/>
@@ -673,20 +608,6 @@
                   </a:p>
                 </c:rich>
               </c:tx>
-              <c:txPr>
-                <a:bodyPr/>
-                <a:lstStyle/>
-                <a:p>
-                  <a:pPr>
-                    <a:defRPr sz="1000" b="1">
-                      <a:solidFill>
-                        <a:srgbClr val="FFFFFF"/>
-                      </a:solidFill>
-                      <a:latin typeface="Calibri"/>
-                    </a:defRPr>
-                  </a:pPr>
-                </a:p>
-              </c:txPr>
               <c:dLblPos val="ctr"/>
               <c:showLegendKey val="0"/>
               <c:showVal val="1"/>
@@ -879,20 +800,6 @@
                   </a:p>
                 </c:rich>
               </c:tx>
-              <c:txPr>
-                <a:bodyPr/>
-                <a:lstStyle/>
-                <a:p>
-                  <a:pPr>
-                    <a:defRPr sz="1000" b="1">
-                      <a:solidFill>
-                        <a:srgbClr val="FFFFFF"/>
-                      </a:solidFill>
-                      <a:latin typeface="Calibri"/>
-                    </a:defRPr>
-                  </a:pPr>
-                </a:p>
-              </c:txPr>
               <c:dLblPos val="ctr"/>
               <c:showLegendKey val="0"/>
               <c:showVal val="1"/>
@@ -920,20 +827,6 @@
                   </a:p>
                 </c:rich>
               </c:tx>
-              <c:txPr>
-                <a:bodyPr/>
-                <a:lstStyle/>
-                <a:p>
-                  <a:pPr>
-                    <a:defRPr sz="1000" b="1">
-                      <a:solidFill>
-                        <a:srgbClr val="FFFFFF"/>
-                      </a:solidFill>
-                      <a:latin typeface="Calibri"/>
-                    </a:defRPr>
-                  </a:pPr>
-                </a:p>
-              </c:txPr>
               <c:dLblPos val="ctr"/>
               <c:showLegendKey val="0"/>
               <c:showVal val="1"/>
@@ -961,20 +854,6 @@
                   </a:p>
                 </c:rich>
               </c:tx>
-              <c:txPr>
-                <a:bodyPr/>
-                <a:lstStyle/>
-                <a:p>
-                  <a:pPr>
-                    <a:defRPr sz="1000" b="1">
-                      <a:solidFill>
-                        <a:srgbClr val="FFFFFF"/>
-                      </a:solidFill>
-                      <a:latin typeface="Calibri"/>
-                    </a:defRPr>
-                  </a:pPr>
-                </a:p>
-              </c:txPr>
               <c:dLblPos val="ctr"/>
               <c:showLegendKey val="0"/>
               <c:showVal val="1"/>
@@ -1002,20 +881,6 @@
                   </a:p>
                 </c:rich>
               </c:tx>
-              <c:txPr>
-                <a:bodyPr/>
-                <a:lstStyle/>
-                <a:p>
-                  <a:pPr>
-                    <a:defRPr sz="1000" b="1">
-                      <a:solidFill>
-                        <a:srgbClr val="FFFFFF"/>
-                      </a:solidFill>
-                      <a:latin typeface="Calibri"/>
-                    </a:defRPr>
-                  </a:pPr>
-                </a:p>
-              </c:txPr>
               <c:dLblPos val="ctr"/>
               <c:showLegendKey val="0"/>
               <c:showVal val="1"/>
@@ -1329,27 +1194,7 @@
 <c:chartSpace xmlns:c="http://schemas.openxmlformats.org/drawingml/2006/chart" xmlns:a="http://schemas.openxmlformats.org/drawingml/2006/main" xmlns:r="http://schemas.openxmlformats.org/officeDocument/2006/relationships">
   <c:date1904 val="0"/>
   <c:chart>
-    <c:title>
-      <c:tx>
-        <c:rich>
-          <a:bodyPr/>
-          <a:lstStyle/>
-          <a:p>
-            <a:r>
-              <a:rPr sz="1300">
-                <a:solidFill>
-                  <a:srgbClr val="16324F"/>
-                </a:solidFill>
-              </a:rPr>
-              <a:t>Most common chronic conditions (% of ED visits, weighted)</a:t>
-            </a:r>
-          </a:p>
-        </c:rich>
-      </c:tx>
-      <c:layout/>
-      <c:overlay val="0"/>
-    </c:title>
-    <c:autoTitleDeleted val="0"/>
+    <c:autoTitleDeleted val="1"/>
     <c:plotArea>
       <c:barChart>
         <c:barDir val="bar"/>
@@ -1373,6 +1218,14 @@
               <a:srgbClr val="2A78D6"/>
             </a:solidFill>
           </c:spPr>
+          <c:dPt>
+            <c:idx val="1"/>
+            <c:spPr>
+              <a:solidFill>
+                <a:srgbClr val="EB6834"/>
+              </a:solidFill>
+            </c:spPr>
+          </c:dPt>
           <c:dLbls>
             <c:numFmt formatCode="0.0&quot;%&quot;" sourceLinked="0"/>
             <c:txPr>
@@ -1380,7 +1233,12 @@
               <a:lstStyle/>
               <a:p>
                 <a:pPr>
-                  <a:defRPr sz="1000"/>
+                  <a:defRPr sz="1100" b="0">
+                    <a:solidFill>
+                      <a:srgbClr val="5A5F66"/>
+                    </a:solidFill>
+                    <a:latin typeface="Calibri"/>
+                  </a:defRPr>
                 </a:pPr>
               </a:p>
             </c:txPr>
@@ -1402,7 +1260,7 @@
                   <c:v>Hypertension</c:v>
                 </c:pt>
                 <c:pt idx="1">
-                  <c:v>Any diabetes</c:v>
+                  <c:v>Any diabetes (type 1, 2 or unspecified)</c:v>
                 </c:pt>
                 <c:pt idx="2">
                   <c:v>Asthma</c:v>
@@ -1531,27 +1389,7 @@
 <c:chartSpace xmlns:c="http://schemas.openxmlformats.org/drawingml/2006/chart" xmlns:a="http://schemas.openxmlformats.org/drawingml/2006/main" xmlns:r="http://schemas.openxmlformats.org/officeDocument/2006/relationships">
   <c:date1904 val="0"/>
   <c:chart>
-    <c:title>
-      <c:tx>
-        <c:rich>
-          <a:bodyPr/>
-          <a:lstStyle/>
-          <a:p>
-            <a:r>
-              <a:rPr sz="1200">
-                <a:solidFill>
-                  <a:srgbClr val="FFFFFF"/>
-                </a:solidFill>
-              </a:rPr>
-              <a:t>Admitted to hospital (%)</a:t>
-            </a:r>
-          </a:p>
-        </c:rich>
-      </c:tx>
-      <c:layout/>
-      <c:overlay val="0"/>
-    </c:title>
-    <c:autoTitleDeleted val="0"/>
+    <c:autoTitleDeleted val="1"/>
     <c:plotArea>
       <c:barChart>
         <c:barDir val="col"/>
@@ -1582,10 +1420,11 @@
               <a:lstStyle/>
               <a:p>
                 <a:pPr>
-                  <a:defRPr sz="1100" b="1">
+                  <a:defRPr sz="1200" b="1">
                     <a:solidFill>
                       <a:srgbClr val="FFFFFF"/>
                     </a:solidFill>
+                    <a:latin typeface="Calibri"/>
                   </a:defRPr>
                 </a:pPr>
               </a:p>
@@ -1699,7 +1538,7 @@
     <a:lstStyle/>
     <a:p>
       <a:pPr>
-        <a:defRPr sz="900">
+        <a:defRPr sz="1000">
           <a:solidFill>
             <a:srgbClr val="CADCFC"/>
           </a:solidFill>
@@ -1719,27 +1558,7 @@
 <c:chartSpace xmlns:c="http://schemas.openxmlformats.org/drawingml/2006/chart" xmlns:a="http://schemas.openxmlformats.org/drawingml/2006/main" xmlns:r="http://schemas.openxmlformats.org/officeDocument/2006/relationships">
   <c:date1904 val="0"/>
   <c:chart>
-    <c:title>
-      <c:tx>
-        <c:rich>
-          <a:bodyPr/>
-          <a:lstStyle/>
-          <a:p>
-            <a:r>
-              <a:rPr sz="1200">
-                <a:solidFill>
-                  <a:srgbClr val="FFFFFF"/>
-                </a:solidFill>
-              </a:rPr>
-              <a:t>Median wait to see a provider (min)</a:t>
-            </a:r>
-          </a:p>
-        </c:rich>
-      </c:tx>
-      <c:layout/>
-      <c:overlay val="0"/>
-    </c:title>
-    <c:autoTitleDeleted val="0"/>
+    <c:autoTitleDeleted val="1"/>
     <c:plotArea>
       <c:barChart>
         <c:barDir val="col"/>
@@ -1753,7 +1572,7 @@
               <c:strCache>
                 <c:ptCount val="1"/>
                 <c:pt idx="0">
-                  <c:v>Median wait to see a provider (min)</c:v>
+                  <c:v>Median recorded wait to see a provider (min)</c:v>
                 </c:pt>
               </c:strCache>
             </c:strRef>
@@ -1770,10 +1589,11 @@
               <a:lstStyle/>
               <a:p>
                 <a:pPr>
-                  <a:defRPr sz="1100" b="1">
+                  <a:defRPr sz="1200" b="1">
                     <a:solidFill>
                       <a:srgbClr val="FFFFFF"/>
                     </a:solidFill>
+                    <a:latin typeface="Calibri"/>
                   </a:defRPr>
                 </a:pPr>
               </a:p>
@@ -1887,7 +1707,7 @@
     <a:lstStyle/>
     <a:p>
       <a:pPr>
-        <a:defRPr sz="900">
+        <a:defRPr sz="1000">
           <a:solidFill>
             <a:srgbClr val="CADCFC"/>
           </a:solidFill>
@@ -2298,7 +2118,7 @@
           <a:lstStyle/>
           <a:p>
             <a:r>
-              <a:t>Each row is one sampled ED visit, not a patient. The main data-quality trap: NCHS stores missing answers as negative codes, so df.isna() misses them. We verified our reading by reproducing NCHS's published nonresponse rates (LOV 7.0%, PAYTYPER 8.7%, IMMEDR 22.2%). Missingness is not random: wait time is missing 38-45% of the time when there was no triage, vs ~10% otherwise.</a:t>
+              <a:t>Each row is one sampled ED visit (one Patient Record Form), not a patient. NCHS stores most missing answers as negative codes, so a standard NaN count understates missingness. Missing wait times are more common where triage was not recorded (38-45%) than at triage levels 1-5 (7-12%), and in the Northeast and West, so wait-time results describe visits with a recorded wait. All results are weighted point estimates without design-based standard errors.</a:t>
             </a:r>
           </a:p>
         </p:txBody>
@@ -2368,7 +2188,7 @@
           <a:lstStyle/>
           <a:p>
             <a:r>
-              <a:t>Weekdays are compared as average visits per day because 2015 had 53 Thursdays. 69% of arrivals come between 10am and 10pm; the single busiest slot is Monday 9-10am (~28,500 visits nationally). By Little's law, ~55,700 patients are in U.S. EDs at any moment, about 12 per ED.</a:t>
+              <a:t>Weekdays are compared as average visits per day because 2015 had 53 Thursdays. Arrivals are lowest from 3am to 6am, climb from 7am, and stay near peak until about 8pm; 69% arrive between 10am and 10pm, and the peak hour has 4.7 times the arrivals of the quietest. The Monday excess is consistent with demand deferred over the weekend, but the data cannot establish why. NHAMCS does not measure occupancy directly.</a:t>
             </a:r>
           </a:p>
         </p:txBody>
@@ -2438,7 +2258,7 @@
           <a:lstStyle/>
           <a:p>
             <a:r>
-              <a:t>PAYTYPER uses an NCHS hierarchy to pick one primary payer per visit; our shares match the codebook exactly (Medicaid 31.15% of all visits). Self-pay peaks at 17.5% among 25-44-year-olds, the main bad-debt exposure.</a:t>
+              <a:t>PAYTYPER is the primary expected source of payment, chosen by an NCHS hierarchy when several are listed; our all-visit shares match the NCHS table (Medicaid 31.15%). 10.8% of visits have a blank or unknown payer and are excluded from the chart. EDs must screen and stabilize patients regardless of ability to pay (EMTALA), so hospitals have little control over this mix at the door.</a:t>
             </a:r>
           </a:p>
         </p:txBody>
@@ -2508,7 +2328,7 @@
           <a:lstStyle/>
           <a:p>
             <a:r>
-              <a:t>Chronic burden rises from 13% of under-15 visits to 90% at 75+. Imaging rises from 29% (children) to 70% (75+). Medications rise from 2.0 per visit with no chronic condition to 3.8 with three or more. Totals match NCHS: 340.6M weighted drug mentions.</a:t>
+              <a:t>The chronic-condition flags describe patients' conditions, not the reason for the visit, so they do not show whether visits were flare-ups or avoidable. Obesity (3.6%) likely understates prevalence because it depends on documentation. Medications rise from 2.0 per visit with no recorded chronic condition to 3.8 with three or more. Injury, overdose and adverse-effect visits (33.1% of visits) are covered in the write-up.</a:t>
             </a:r>
           </a:p>
         </p:txBody>
@@ -2578,7 +2398,7 @@
           <a:lstStyle/>
           <a:p>
             <a:r>
-              <a:t>Admission falls from 33% for immediate patients to 2-3% for semi- and nonurgent, but median waits are 14 minutes for immediate and 18-20 for every other level. Correlations are associations, not causal effects; age drives chronic burden, payer and treatment intensity together. Limitations: point estimates without survey-design standard errors.</a:t>
+              <a:t>Admission falls from 33% at level 1 to 2-3% at levels 4-5 (9.0% overall), consistent with triage identifying sicker patients. The wait comparison is descriptive and uses only visits with a recorded wait. ED deaths (28 sampled records) and dead-on-arrival cases (7) are below the 30-record threshold NCHS uses for reliable estimates, so they are not broken out here.</a:t>
             </a:r>
           </a:p>
         </p:txBody>
@@ -5620,7 +5440,7 @@
               </a:spcAft>
             </a:pPr>
             <a:r>
-              <a:rPr sz="1300" b="1" i="0">
+              <a:rPr sz="1300" b="1">
                 <a:solidFill>
                   <a:srgbClr val="CADCFC"/>
                 </a:solidFill>
@@ -5640,7 +5460,7 @@
         <p:spPr>
           <a:xfrm>
             <a:off x="548640" y="868680"/>
-            <a:ext cx="10972800" cy="1280160"/>
+            <a:ext cx="11064240" cy="1280160"/>
           </a:xfrm>
           <a:prstGeom prst="rect">
             <a:avLst/>
@@ -5659,13 +5479,13 @@
               </a:spcAft>
             </a:pPr>
             <a:r>
-              <a:rPr sz="3600" b="1" i="0">
+              <a:rPr sz="3400" b="1">
                 <a:solidFill>
                   <a:srgbClr val="FFFFFF"/>
                 </a:solidFill>
                 <a:latin typeface="Cambria"/>
               </a:rPr>
-              <a:t>137 million ED visits: what a national sample tells hospital managers</a:t>
+              <a:t>137 million ED visits: what the 2015 national sample shows hospital managers</a:t>
             </a:r>
           </a:p>
         </p:txBody>
@@ -5698,73 +5518,27 @@
               </a:spcAft>
             </a:pPr>
             <a:r>
-              <a:rPr sz="1400" b="0" i="0">
+              <a:rPr sz="1400" b="0">
                 <a:solidFill>
                   <a:srgbClr val="CADCFC"/>
                 </a:solidFill>
                 <a:latin typeface="Calibri"/>
               </a:rPr>
-              <a:t>Group: Michal Kozuchowski, Laila Lapins, Nick Giamalis, Raymond Chang, Sean Weller</a:t>
-            </a:r>
-          </a:p>
-        </p:txBody>
-      </p:sp>
-      <p:sp>
-        <p:nvSpPr>
-          <p:cNvPr id="5" name="Rounded Rectangle 4"/>
-          <p:cNvSpPr/>
+              <a:t>Michal Kozuchowski, Laila Lapins, Nick Giamalis, Raymond Chang, Sean Weller</a:t>
+            </a:r>
+          </a:p>
+        </p:txBody>
+      </p:sp>
+      <p:sp>
+        <p:nvSpPr>
+          <p:cNvPr id="5" name="TextBox 4"/>
+          <p:cNvSpPr txBox="1"/>
           <p:nvPr/>
         </p:nvSpPr>
         <p:spPr>
           <a:xfrm>
-            <a:off x="548640" y="2788920"/>
-            <a:ext cx="2606040" cy="1600200"/>
-          </a:xfrm>
-          <a:prstGeom prst="roundRect">
-            <a:avLst>
-              <a:gd name="adj" fmla="val 8000"/>
-            </a:avLst>
-          </a:prstGeom>
-          <a:solidFill>
-            <a:srgbClr val="22466C"/>
-          </a:solidFill>
-          <a:ln>
-            <a:noFill/>
-          </a:ln>
-          <a:effectLst/>
-        </p:spPr>
-        <p:style>
-          <a:lnRef idx="1">
-            <a:schemeClr val="accent1"/>
-          </a:lnRef>
-          <a:fillRef idx="3">
-            <a:schemeClr val="accent1"/>
-          </a:fillRef>
-          <a:effectRef idx="2">
-            <a:schemeClr val="accent1"/>
-          </a:effectRef>
-          <a:fontRef idx="minor">
-            <a:schemeClr val="lt1"/>
-          </a:fontRef>
-        </p:style>
-        <p:txBody>
-          <a:bodyPr rtlCol="0" anchor="ctr"/>
-          <a:lstStyle/>
-          <a:p>
-            <a:pPr algn="ctr"/>
-          </a:p>
-        </p:txBody>
-      </p:sp>
-      <p:sp>
-        <p:nvSpPr>
-          <p:cNvPr id="6" name="TextBox 5"/>
-          <p:cNvSpPr txBox="1"/>
-          <p:nvPr/>
-        </p:nvSpPr>
-        <p:spPr>
-          <a:xfrm>
-            <a:off x="777240" y="2953512"/>
-            <a:ext cx="2148840" cy="685800"/>
+            <a:off x="548640" y="2880360"/>
+            <a:ext cx="3383280" cy="685800"/>
           </a:xfrm>
           <a:prstGeom prst="rect">
             <a:avLst/>
@@ -5783,7 +5557,7 @@
               </a:spcAft>
             </a:pPr>
             <a:r>
-              <a:rPr sz="3400" b="1" i="0">
+              <a:rPr sz="4000" b="1">
                 <a:solidFill>
                   <a:srgbClr val="FFFFFF"/>
                 </a:solidFill>
@@ -5796,14 +5570,14 @@
       </p:sp>
       <p:sp>
         <p:nvSpPr>
-          <p:cNvPr id="7" name="TextBox 6"/>
+          <p:cNvPr id="6" name="TextBox 5"/>
           <p:cNvSpPr txBox="1"/>
           <p:nvPr/>
         </p:nvSpPr>
         <p:spPr>
           <a:xfrm>
-            <a:off x="777240" y="3630168"/>
-            <a:ext cx="2148840" cy="685800"/>
+            <a:off x="548640" y="3538728"/>
+            <a:ext cx="3383280" cy="822960"/>
           </a:xfrm>
           <a:prstGeom prst="rect">
             <a:avLst/>
@@ -5822,73 +5596,27 @@
               </a:spcAft>
             </a:pPr>
             <a:r>
-              <a:rPr sz="1250" b="0" i="0">
+              <a:rPr sz="1300" b="0">
                 <a:solidFill>
                   <a:srgbClr val="CADCFC"/>
                 </a:solidFill>
                 <a:latin typeface="Calibri"/>
               </a:rPr>
-              <a:t>sampled visits (rows) from 248 EDs, 1,031 variables</a:t>
-            </a:r>
-          </a:p>
-        </p:txBody>
-      </p:sp>
-      <p:sp>
-        <p:nvSpPr>
-          <p:cNvPr id="8" name="Rounded Rectangle 7"/>
-          <p:cNvSpPr/>
+              <a:t>sampled visits from 248 EDs; each row is one visit, not one patient</a:t>
+            </a:r>
+          </a:p>
+        </p:txBody>
+      </p:sp>
+      <p:sp>
+        <p:nvSpPr>
+          <p:cNvPr id="7" name="TextBox 6"/>
+          <p:cNvSpPr txBox="1"/>
           <p:nvPr/>
         </p:nvSpPr>
         <p:spPr>
           <a:xfrm>
-            <a:off x="3383280" y="2788920"/>
-            <a:ext cx="2606040" cy="1600200"/>
-          </a:xfrm>
-          <a:prstGeom prst="roundRect">
-            <a:avLst>
-              <a:gd name="adj" fmla="val 8000"/>
-            </a:avLst>
-          </a:prstGeom>
-          <a:solidFill>
-            <a:srgbClr val="22466C"/>
-          </a:solidFill>
-          <a:ln>
-            <a:noFill/>
-          </a:ln>
-          <a:effectLst/>
-        </p:spPr>
-        <p:style>
-          <a:lnRef idx="1">
-            <a:schemeClr val="accent1"/>
-          </a:lnRef>
-          <a:fillRef idx="3">
-            <a:schemeClr val="accent1"/>
-          </a:fillRef>
-          <a:effectRef idx="2">
-            <a:schemeClr val="accent1"/>
-          </a:effectRef>
-          <a:fontRef idx="minor">
-            <a:schemeClr val="lt1"/>
-          </a:fontRef>
-        </p:style>
-        <p:txBody>
-          <a:bodyPr rtlCol="0" anchor="ctr"/>
-          <a:lstStyle/>
-          <a:p>
-            <a:pPr algn="ctr"/>
-          </a:p>
-        </p:txBody>
-      </p:sp>
-      <p:sp>
-        <p:nvSpPr>
-          <p:cNvPr id="9" name="TextBox 8"/>
-          <p:cNvSpPr txBox="1"/>
-          <p:nvPr/>
-        </p:nvSpPr>
-        <p:spPr>
-          <a:xfrm>
-            <a:off x="3611880" y="2953512"/>
-            <a:ext cx="2148840" cy="685800"/>
+            <a:off x="4297679" y="2880360"/>
+            <a:ext cx="3383280" cy="685800"/>
           </a:xfrm>
           <a:prstGeom prst="rect">
             <a:avLst/>
@@ -5907,7 +5635,7 @@
               </a:spcAft>
             </a:pPr>
             <a:r>
-              <a:rPr sz="3400" b="1" i="0">
+              <a:rPr sz="4000" b="1">
                 <a:solidFill>
                   <a:srgbClr val="FFFFFF"/>
                 </a:solidFill>
@@ -5920,14 +5648,14 @@
       </p:sp>
       <p:sp>
         <p:nvSpPr>
-          <p:cNvPr id="10" name="TextBox 9"/>
+          <p:cNvPr id="8" name="TextBox 7"/>
           <p:cNvSpPr txBox="1"/>
           <p:nvPr/>
         </p:nvSpPr>
         <p:spPr>
           <a:xfrm>
-            <a:off x="3611880" y="3630168"/>
-            <a:ext cx="2148840" cy="685800"/>
+            <a:off x="4297679" y="3538728"/>
+            <a:ext cx="3383280" cy="822960"/>
           </a:xfrm>
           <a:prstGeom prst="rect">
             <a:avLst/>
@@ -5946,73 +5674,27 @@
               </a:spcAft>
             </a:pPr>
             <a:r>
-              <a:rPr sz="1250" b="0" i="0">
+              <a:rPr sz="1300" b="0">
                 <a:solidFill>
                   <a:srgbClr val="CADCFC"/>
                 </a:solidFill>
                 <a:latin typeface="Calibri"/>
               </a:rPr>
-              <a:t>U.S. ED visits once weighted by PATWT, exactly the NCHS total</a:t>
-            </a:r>
-          </a:p>
-        </p:txBody>
-      </p:sp>
-      <p:sp>
-        <p:nvSpPr>
-          <p:cNvPr id="11" name="Rounded Rectangle 10"/>
-          <p:cNvSpPr/>
+              <a:t>U.S. ED visits once weighted by PATWT, matching the NCHS-published total</a:t>
+            </a:r>
+          </a:p>
+        </p:txBody>
+      </p:sp>
+      <p:sp>
+        <p:nvSpPr>
+          <p:cNvPr id="9" name="TextBox 8"/>
+          <p:cNvSpPr txBox="1"/>
           <p:nvPr/>
         </p:nvSpPr>
         <p:spPr>
           <a:xfrm>
-            <a:off x="6217920" y="2788920"/>
-            <a:ext cx="2606040" cy="1600200"/>
-          </a:xfrm>
-          <a:prstGeom prst="roundRect">
-            <a:avLst>
-              <a:gd name="adj" fmla="val 8000"/>
-            </a:avLst>
-          </a:prstGeom>
-          <a:solidFill>
-            <a:srgbClr val="22466C"/>
-          </a:solidFill>
-          <a:ln>
-            <a:noFill/>
-          </a:ln>
-          <a:effectLst/>
-        </p:spPr>
-        <p:style>
-          <a:lnRef idx="1">
-            <a:schemeClr val="accent1"/>
-          </a:lnRef>
-          <a:fillRef idx="3">
-            <a:schemeClr val="accent1"/>
-          </a:fillRef>
-          <a:effectRef idx="2">
-            <a:schemeClr val="accent1"/>
-          </a:effectRef>
-          <a:fontRef idx="minor">
-            <a:schemeClr val="lt1"/>
-          </a:fontRef>
-        </p:style>
-        <p:txBody>
-          <a:bodyPr rtlCol="0" anchor="ctr"/>
-          <a:lstStyle/>
-          <a:p>
-            <a:pPr algn="ctr"/>
-          </a:p>
-        </p:txBody>
-      </p:sp>
-      <p:sp>
-        <p:nvSpPr>
-          <p:cNvPr id="12" name="TextBox 11"/>
-          <p:cNvSpPr txBox="1"/>
-          <p:nvPr/>
-        </p:nvSpPr>
-        <p:spPr>
-          <a:xfrm>
-            <a:off x="6446520" y="2953512"/>
-            <a:ext cx="2148840" cy="685800"/>
+            <a:off x="8046719" y="2880360"/>
+            <a:ext cx="3383280" cy="685800"/>
           </a:xfrm>
           <a:prstGeom prst="rect">
             <a:avLst/>
@@ -6031,7 +5713,7 @@
               </a:spcAft>
             </a:pPr>
             <a:r>
-              <a:rPr sz="3400" b="1" i="0">
+              <a:rPr sz="4000" b="1">
                 <a:solidFill>
                   <a:srgbClr val="FFFFFF"/>
                 </a:solidFill>
@@ -6044,14 +5726,14 @@
       </p:sp>
       <p:sp>
         <p:nvSpPr>
-          <p:cNvPr id="13" name="TextBox 12"/>
+          <p:cNvPr id="10" name="TextBox 9"/>
           <p:cNvSpPr txBox="1"/>
           <p:nvPr/>
         </p:nvSpPr>
         <p:spPr>
           <a:xfrm>
-            <a:off x="6446520" y="3630168"/>
-            <a:ext cx="2148840" cy="685800"/>
+            <a:off x="8046719" y="3538728"/>
+            <a:ext cx="3383280" cy="822960"/>
           </a:xfrm>
           <a:prstGeom prst="rect">
             <a:avLst/>
@@ -6070,73 +5752,27 @@
               </a:spcAft>
             </a:pPr>
             <a:r>
-              <a:rPr sz="1250" b="0" i="0">
+              <a:rPr sz="1300" b="0">
                 <a:solidFill>
                   <a:srgbClr val="CADCFC"/>
                 </a:solidFill>
                 <a:latin typeface="Calibri"/>
               </a:rPr>
-              <a:t>blank / unknown / N/A codes, hidden missing data we removed</a:t>
-            </a:r>
-          </a:p>
-        </p:txBody>
-      </p:sp>
-      <p:sp>
-        <p:nvSpPr>
-          <p:cNvPr id="14" name="Rounded Rectangle 13"/>
-          <p:cNvSpPr/>
+              <a:t>codes NCHS uses for blank, unknown and not-applicable answers; recoded to missing</a:t>
+            </a:r>
+          </a:p>
+        </p:txBody>
+      </p:sp>
+      <p:sp>
+        <p:nvSpPr>
+          <p:cNvPr id="11" name="TextBox 10"/>
+          <p:cNvSpPr txBox="1"/>
           <p:nvPr/>
         </p:nvSpPr>
         <p:spPr>
           <a:xfrm>
-            <a:off x="9052560" y="2788920"/>
-            <a:ext cx="2606040" cy="1600200"/>
-          </a:xfrm>
-          <a:prstGeom prst="roundRect">
-            <a:avLst>
-              <a:gd name="adj" fmla="val 8000"/>
-            </a:avLst>
-          </a:prstGeom>
-          <a:solidFill>
-            <a:srgbClr val="22466C"/>
-          </a:solidFill>
-          <a:ln>
-            <a:noFill/>
-          </a:ln>
-          <a:effectLst/>
-        </p:spPr>
-        <p:style>
-          <a:lnRef idx="1">
-            <a:schemeClr val="accent1"/>
-          </a:lnRef>
-          <a:fillRef idx="3">
-            <a:schemeClr val="accent1"/>
-          </a:fillRef>
-          <a:effectRef idx="2">
-            <a:schemeClr val="accent1"/>
-          </a:effectRef>
-          <a:fontRef idx="minor">
-            <a:schemeClr val="lt1"/>
-          </a:fontRef>
-        </p:style>
-        <p:txBody>
-          <a:bodyPr rtlCol="0" anchor="ctr"/>
-          <a:lstStyle/>
-          <a:p>
-            <a:pPr algn="ctr"/>
-          </a:p>
-        </p:txBody>
-      </p:sp>
-      <p:sp>
-        <p:nvSpPr>
-          <p:cNvPr id="15" name="TextBox 14"/>
-          <p:cNvSpPr txBox="1"/>
-          <p:nvPr/>
-        </p:nvSpPr>
-        <p:spPr>
-          <a:xfrm>
-            <a:off x="9281160" y="2953512"/>
-            <a:ext cx="2148840" cy="685800"/>
+            <a:off x="548640" y="4800600"/>
+            <a:ext cx="11064240" cy="1463040"/>
           </a:xfrm>
           <a:prstGeom prst="rect">
             <a:avLst/>
@@ -6155,38 +5791,15 @@
               </a:spcAft>
             </a:pPr>
             <a:r>
-              <a:rPr sz="3400" b="1" i="0">
+              <a:rPr sz="1500" b="1">
                 <a:solidFill>
                   <a:srgbClr val="FFFFFF"/>
                 </a:solidFill>
-                <a:latin typeface="Cambria"/>
+                <a:latin typeface="Calibri"/>
               </a:rPr>
-              <a:t>20 / 20</a:t>
-            </a:r>
-          </a:p>
-        </p:txBody>
-      </p:sp>
-      <p:sp>
-        <p:nvSpPr>
-          <p:cNvPr id="16" name="TextBox 15"/>
-          <p:cNvSpPr txBox="1"/>
-          <p:nvPr/>
-        </p:nvSpPr>
-        <p:spPr>
-          <a:xfrm>
-            <a:off x="9281160" y="3630168"/>
-            <a:ext cx="2148840" cy="685800"/>
-          </a:xfrm>
-          <a:prstGeom prst="rect">
-            <a:avLst/>
-          </a:prstGeom>
-          <a:noFill/>
-        </p:spPr>
-        <p:txBody>
-          <a:bodyPr wrap="square" anchor="t" lIns="0" rIns="0" tIns="0" bIns="0">
-            <a:spAutoFit/>
-          </a:bodyPr>
-          <a:lstStyle/>
+              <a:t>Method</a:t>
+            </a:r>
+          </a:p>
           <a:p>
             <a:pPr algn="l">
               <a:spcAft>
@@ -6194,68 +5807,13 @@
               </a:spcAft>
             </a:pPr>
             <a:r>
-              <a:rPr sz="1250" b="0" i="0">
+              <a:rPr sz="1400" b="0">
                 <a:solidFill>
                   <a:srgbClr val="CADCFC"/>
                 </a:solidFill>
                 <a:latin typeface="Calibri"/>
               </a:rPr>
-              <a:t>checks against published NCHS figures pass</a:t>
-            </a:r>
-          </a:p>
-        </p:txBody>
-      </p:sp>
-      <p:sp>
-        <p:nvSpPr>
-          <p:cNvPr id="17" name="TextBox 16"/>
-          <p:cNvSpPr txBox="1"/>
-          <p:nvPr/>
-        </p:nvSpPr>
-        <p:spPr>
-          <a:xfrm>
-            <a:off x="548640" y="4754880"/>
-            <a:ext cx="11064240" cy="1645920"/>
-          </a:xfrm>
-          <a:prstGeom prst="rect">
-            <a:avLst/>
-          </a:prstGeom>
-          <a:noFill/>
-        </p:spPr>
-        <p:txBody>
-          <a:bodyPr wrap="square" anchor="t" lIns="0" rIns="0" tIns="0" bIns="0">
-            <a:spAutoFit/>
-          </a:bodyPr>
-          <a:lstStyle/>
-          <a:p>
-            <a:pPr algn="l">
-              <a:spcAft>
-                <a:spcPts val="600"/>
-              </a:spcAft>
-            </a:pPr>
-            <a:r>
-              <a:rPr sz="1500" b="1" i="0">
-                <a:solidFill>
-                  <a:srgbClr val="FFFFFF"/>
-                </a:solidFill>
-                <a:latin typeface="Calibri"/>
-              </a:rPr>
-              <a:t>Approach</a:t>
-            </a:r>
-          </a:p>
-          <a:p>
-            <a:pPr algn="l">
-              <a:spcAft>
-                <a:spcPts val="600"/>
-              </a:spcAft>
-            </a:pPr>
-            <a:r>
-              <a:rPr sz="1400" b="0" i="0">
-                <a:solidFill>
-                  <a:srgbClr val="CADCFC"/>
-                </a:solidFill>
-                <a:latin typeface="Calibri"/>
-              </a:rPr>
-              <a:t>Load → recode missing-value codes → weight every estimate → cap extreme waits and stays at the 99.5th percentile → check each result against the codebook. One commented notebook, one cell per question, re-run cleanly end to end.</a:t>
+              <a:t>Every estimate weighted by PATWT. Missing-value codes recoded before any statistic. Long waits and stays summarized with medians; means reported with values capped at the 99.5th percentile. Key estimates compared with figures NCHS publishes: all agree to rounding except wait-time missingness (15.2% vs 15.7%).</a:t>
             </a:r>
           </a:p>
         </p:txBody>
@@ -6294,8 +5852,8 @@
         </p:nvSpPr>
         <p:spPr>
           <a:xfrm>
-            <a:off x="548640" y="365760"/>
-            <a:ext cx="11064240" cy="731520"/>
+            <a:off x="548640" y="320040"/>
+            <a:ext cx="11064240" cy="914400"/>
           </a:xfrm>
           <a:prstGeom prst="rect">
             <a:avLst/>
@@ -6314,13 +5872,13 @@
               </a:spcAft>
             </a:pPr>
             <a:r>
-              <a:rPr sz="3000" b="1" i="0">
+              <a:rPr sz="2600" b="1">
                 <a:solidFill>
                   <a:srgbClr val="16324F"/>
                 </a:solidFill>
                 <a:latin typeface="Cambria"/>
               </a:rPr>
-              <a:t>Demand is predictable: 10am-8pm plateau, Monday peak</a:t>
+              <a:t>Arrivals stay near peak from 10am to 8pm, and the median visit lasts 2.6 hours</a:t>
             </a:r>
           </a:p>
         </p:txBody>
@@ -6333,8 +5891,8 @@
         </p:nvSpPr>
         <p:spPr>
           <a:xfrm>
-            <a:off x="548640" y="1024128"/>
-            <a:ext cx="11064240" cy="411480"/>
+            <a:off x="548640" y="1261872"/>
+            <a:ext cx="11064240" cy="365760"/>
           </a:xfrm>
           <a:prstGeom prst="rect">
             <a:avLst/>
@@ -6353,13 +5911,13 @@
               </a:spcAft>
             </a:pPr>
             <a:r>
-              <a:rPr sz="1500" b="0" i="0">
+              <a:rPr sz="1400" b="0">
                 <a:solidFill>
                   <a:srgbClr val="5A5F66"/>
                 </a:solidFill>
                 <a:latin typeface="Calibri"/>
               </a:rPr>
-              <a:t>Weighted share of daily ED arrivals by hour of arrival, 2015</a:t>
+              <a:t>Weighted share of daily arrivals by hour (visits with a recorded arrival time, 98.7% of records)</a:t>
             </a:r>
           </a:p>
         </p:txBody>
@@ -6373,8 +5931,8 @@
           <p:nvPr/>
         </p:nvGraphicFramePr>
         <p:xfrm>
-          <a:off x="457200" y="1554480"/>
-          <a:ext cx="7589520" cy="4754880"/>
+          <a:off x="457200" y="1783080"/>
+          <a:ext cx="7680960" cy="4663440"/>
         </p:xfrm>
         <a:graphic>
           <a:graphicData uri="http://schemas.openxmlformats.org/drawingml/2006/chart">
@@ -6384,60 +5942,14 @@
       </p:graphicFrame>
       <p:sp>
         <p:nvSpPr>
-          <p:cNvPr id="5" name="Rounded Rectangle 4"/>
-          <p:cNvSpPr/>
+          <p:cNvPr id="5" name="TextBox 4"/>
+          <p:cNvSpPr txBox="1"/>
           <p:nvPr/>
         </p:nvSpPr>
         <p:spPr>
           <a:xfrm>
-            <a:off x="8412480" y="1600200"/>
-            <a:ext cx="3291840" cy="1417320"/>
-          </a:xfrm>
-          <a:prstGeom prst="roundRect">
-            <a:avLst>
-              <a:gd name="adj" fmla="val 8000"/>
-            </a:avLst>
-          </a:prstGeom>
-          <a:solidFill>
-            <a:srgbClr val="ECF1F7"/>
-          </a:solidFill>
-          <a:ln>
-            <a:noFill/>
-          </a:ln>
-          <a:effectLst/>
-        </p:spPr>
-        <p:style>
-          <a:lnRef idx="1">
-            <a:schemeClr val="accent1"/>
-          </a:lnRef>
-          <a:fillRef idx="3">
-            <a:schemeClr val="accent1"/>
-          </a:fillRef>
-          <a:effectRef idx="2">
-            <a:schemeClr val="accent1"/>
-          </a:effectRef>
-          <a:fontRef idx="minor">
-            <a:schemeClr val="lt1"/>
-          </a:fontRef>
-        </p:style>
-        <p:txBody>
-          <a:bodyPr rtlCol="0" anchor="ctr"/>
-          <a:lstStyle/>
-          <a:p>
-            <a:pPr algn="ctr"/>
-          </a:p>
-        </p:txBody>
-      </p:sp>
-      <p:sp>
-        <p:nvSpPr>
-          <p:cNvPr id="6" name="TextBox 5"/>
-          <p:cNvSpPr txBox="1"/>
-          <p:nvPr/>
-        </p:nvSpPr>
-        <p:spPr>
-          <a:xfrm>
-            <a:off x="8641080" y="1764792"/>
-            <a:ext cx="2834640" cy="685800"/>
+            <a:off x="8595360" y="1920240"/>
+            <a:ext cx="3108960" cy="685800"/>
           </a:xfrm>
           <a:prstGeom prst="rect">
             <a:avLst/>
@@ -6456,27 +5968,27 @@
               </a:spcAft>
             </a:pPr>
             <a:r>
-              <a:rPr sz="3400" b="1" i="0">
+              <a:rPr sz="3800" b="1">
                 <a:solidFill>
                   <a:srgbClr val="16324F"/>
                 </a:solidFill>
                 <a:latin typeface="Cambria"/>
               </a:rPr>
-              <a:t>4.7x</a:t>
-            </a:r>
-          </a:p>
-        </p:txBody>
-      </p:sp>
-      <p:sp>
-        <p:nvSpPr>
-          <p:cNvPr id="7" name="TextBox 6"/>
+              <a:t>154 min</a:t>
+            </a:r>
+          </a:p>
+        </p:txBody>
+      </p:sp>
+      <p:sp>
+        <p:nvSpPr>
+          <p:cNvPr id="6" name="TextBox 5"/>
           <p:cNvSpPr txBox="1"/>
           <p:nvPr/>
         </p:nvSpPr>
         <p:spPr>
           <a:xfrm>
-            <a:off x="8641080" y="2441448"/>
-            <a:ext cx="2834640" cy="502920"/>
+            <a:off x="8595360" y="2578608"/>
+            <a:ext cx="3108960" cy="822960"/>
           </a:xfrm>
           <a:prstGeom prst="rect">
             <a:avLst/>
@@ -6495,73 +6007,27 @@
               </a:spcAft>
             </a:pPr>
             <a:r>
-              <a:rPr sz="1250" b="0" i="0">
+              <a:rPr sz="1300" b="0">
                 <a:solidFill>
                   <a:srgbClr val="5A5F66"/>
                 </a:solidFill>
                 <a:latin typeface="Calibri"/>
               </a:rPr>
-              <a:t>arrivals in the 6pm peak hour vs the 5am trough</a:t>
-            </a:r>
-          </a:p>
-        </p:txBody>
-      </p:sp>
-      <p:sp>
-        <p:nvSpPr>
-          <p:cNvPr id="8" name="Rounded Rectangle 7"/>
-          <p:cNvSpPr/>
+              <a:t>median length of visit (mean 214 min)</a:t>
+            </a:r>
+          </a:p>
+        </p:txBody>
+      </p:sp>
+      <p:sp>
+        <p:nvSpPr>
+          <p:cNvPr id="7" name="TextBox 6"/>
+          <p:cNvSpPr txBox="1"/>
           <p:nvPr/>
         </p:nvSpPr>
         <p:spPr>
           <a:xfrm>
-            <a:off x="8412480" y="3200400"/>
-            <a:ext cx="3291840" cy="1417320"/>
-          </a:xfrm>
-          <a:prstGeom prst="roundRect">
-            <a:avLst>
-              <a:gd name="adj" fmla="val 8000"/>
-            </a:avLst>
-          </a:prstGeom>
-          <a:solidFill>
-            <a:srgbClr val="ECF1F7"/>
-          </a:solidFill>
-          <a:ln>
-            <a:noFill/>
-          </a:ln>
-          <a:effectLst/>
-        </p:spPr>
-        <p:style>
-          <a:lnRef idx="1">
-            <a:schemeClr val="accent1"/>
-          </a:lnRef>
-          <a:fillRef idx="3">
-            <a:schemeClr val="accent1"/>
-          </a:fillRef>
-          <a:effectRef idx="2">
-            <a:schemeClr val="accent1"/>
-          </a:effectRef>
-          <a:fontRef idx="minor">
-            <a:schemeClr val="lt1"/>
-          </a:fontRef>
-        </p:style>
-        <p:txBody>
-          <a:bodyPr rtlCol="0" anchor="ctr"/>
-          <a:lstStyle/>
-          <a:p>
-            <a:pPr algn="ctr"/>
-          </a:p>
-        </p:txBody>
-      </p:sp>
-      <p:sp>
-        <p:nvSpPr>
-          <p:cNvPr id="9" name="TextBox 8"/>
-          <p:cNvSpPr txBox="1"/>
-          <p:nvPr/>
-        </p:nvSpPr>
-        <p:spPr>
-          <a:xfrm>
-            <a:off x="8641080" y="3364992"/>
-            <a:ext cx="2834640" cy="685800"/>
+            <a:off x="8595360" y="3246120"/>
+            <a:ext cx="3108960" cy="685800"/>
           </a:xfrm>
           <a:prstGeom prst="rect">
             <a:avLst/>
@@ -6580,7 +6046,7 @@
               </a:spcAft>
             </a:pPr>
             <a:r>
-              <a:rPr sz="3400" b="1" i="0">
+              <a:rPr sz="3800" b="1">
                 <a:solidFill>
                   <a:srgbClr val="16324F"/>
                 </a:solidFill>
@@ -6593,14 +6059,14 @@
       </p:sp>
       <p:sp>
         <p:nvSpPr>
-          <p:cNvPr id="10" name="TextBox 9"/>
+          <p:cNvPr id="8" name="TextBox 7"/>
           <p:cNvSpPr txBox="1"/>
           <p:nvPr/>
         </p:nvSpPr>
         <p:spPr>
           <a:xfrm>
-            <a:off x="8641080" y="4041648"/>
-            <a:ext cx="2834640" cy="502920"/>
+            <a:off x="8595360" y="3904487"/>
+            <a:ext cx="3108960" cy="822960"/>
           </a:xfrm>
           <a:prstGeom prst="rect">
             <a:avLst/>
@@ -6619,73 +6085,27 @@
               </a:spcAft>
             </a:pPr>
             <a:r>
-              <a:rPr sz="1250" b="0" i="0">
+              <a:rPr sz="1300" b="0">
                 <a:solidFill>
                   <a:srgbClr val="5A5F66"/>
                 </a:solidFill>
                 <a:latin typeface="Calibri"/>
               </a:rPr>
-              <a:t>Monday (432k visits/day) vs Sunday (346k), average per day</a:t>
-            </a:r>
-          </a:p>
-        </p:txBody>
-      </p:sp>
-      <p:sp>
-        <p:nvSpPr>
-          <p:cNvPr id="11" name="Rounded Rectangle 10"/>
-          <p:cNvSpPr/>
+              <a:t>visits per day on Mondays vs Sundays (432,000 vs 346,000)</a:t>
+            </a:r>
+          </a:p>
+        </p:txBody>
+      </p:sp>
+      <p:sp>
+        <p:nvSpPr>
+          <p:cNvPr id="9" name="TextBox 8"/>
+          <p:cNvSpPr txBox="1"/>
           <p:nvPr/>
         </p:nvSpPr>
         <p:spPr>
           <a:xfrm>
-            <a:off x="8412480" y="4800600"/>
-            <a:ext cx="3291840" cy="1508760"/>
-          </a:xfrm>
-          <a:prstGeom prst="roundRect">
-            <a:avLst>
-              <a:gd name="adj" fmla="val 8000"/>
-            </a:avLst>
-          </a:prstGeom>
-          <a:solidFill>
-            <a:srgbClr val="ECF1F7"/>
-          </a:solidFill>
-          <a:ln>
-            <a:noFill/>
-          </a:ln>
-          <a:effectLst/>
-        </p:spPr>
-        <p:style>
-          <a:lnRef idx="1">
-            <a:schemeClr val="accent1"/>
-          </a:lnRef>
-          <a:fillRef idx="3">
-            <a:schemeClr val="accent1"/>
-          </a:fillRef>
-          <a:effectRef idx="2">
-            <a:schemeClr val="accent1"/>
-          </a:effectRef>
-          <a:fontRef idx="minor">
-            <a:schemeClr val="lt1"/>
-          </a:fontRef>
-        </p:style>
-        <p:txBody>
-          <a:bodyPr rtlCol="0" anchor="ctr"/>
-          <a:lstStyle/>
-          <a:p>
-            <a:pPr algn="ctr"/>
-          </a:p>
-        </p:txBody>
-      </p:sp>
-      <p:sp>
-        <p:nvSpPr>
-          <p:cNvPr id="12" name="TextBox 11"/>
-          <p:cNvSpPr txBox="1"/>
-          <p:nvPr/>
-        </p:nvSpPr>
-        <p:spPr>
-          <a:xfrm>
-            <a:off x="8641080" y="4937760"/>
-            <a:ext cx="2834640" cy="1280160"/>
+            <a:off x="8595360" y="4663440"/>
+            <a:ext cx="3108960" cy="1737360"/>
           </a:xfrm>
           <a:prstGeom prst="rect">
             <a:avLst/>
@@ -6704,29 +6124,13 @@
               </a:spcAft>
             </a:pPr>
             <a:r>
-              <a:rPr sz="1300" b="1" i="0">
-                <a:solidFill>
-                  <a:srgbClr val="16324F"/>
-                </a:solidFill>
-                <a:latin typeface="Calibri"/>
-              </a:rPr>
-              <a:t>Staffing</a:t>
-            </a:r>
-          </a:p>
-          <a:p>
-            <a:pPr algn="l">
-              <a:spcAft>
-                <a:spcPts val="600"/>
-              </a:spcAft>
-            </a:pPr>
-            <a:r>
-              <a:rPr sz="1200" b="0" i="0">
+              <a:rPr sz="1300" b="0">
                 <a:solidFill>
                   <a:srgbClr val="1A1A1A"/>
                 </a:solidFill>
                 <a:latin typeface="Calibri"/>
               </a:rPr>
-              <a:t>Stagger shifts through the 7-10am ramp, keep full coverage to ~midnight (median stay 2.6 h), and roster heavier on Mondays.</a:t>
+              <a:t>Because patients stay about 2.6 hours, the number in the department likely peaks after arrivals do. Staffing plans should weigh time in the department, not arrivals alone.</a:t>
             </a:r>
           </a:p>
         </p:txBody>
@@ -6765,8 +6169,8 @@
         </p:nvSpPr>
         <p:spPr>
           <a:xfrm>
-            <a:off x="548640" y="365760"/>
-            <a:ext cx="11064240" cy="731520"/>
+            <a:off x="548640" y="320040"/>
+            <a:ext cx="11064240" cy="914400"/>
           </a:xfrm>
           <a:prstGeom prst="rect">
             <a:avLst/>
@@ -6785,13 +6189,13 @@
               </a:spcAft>
             </a:pPr>
             <a:r>
-              <a:rPr sz="3000" b="1" i="0">
+              <a:rPr sz="2600" b="1">
                 <a:solidFill>
                   <a:srgbClr val="16324F"/>
                 </a:solidFill>
                 <a:latin typeface="Cambria"/>
               </a:rPr>
-              <a:t>Public payers fund most ED visits, and age decides who pays</a:t>
+              <a:t>Medicaid is the most common expected payer, and age largely determines who pays</a:t>
             </a:r>
           </a:p>
         </p:txBody>
@@ -6804,8 +6208,8 @@
         </p:nvSpPr>
         <p:spPr>
           <a:xfrm>
-            <a:off x="548640" y="1024128"/>
-            <a:ext cx="11064240" cy="411480"/>
+            <a:off x="548640" y="1261872"/>
+            <a:ext cx="11064240" cy="365760"/>
           </a:xfrm>
           <a:prstGeom prst="rect">
             <a:avLst/>
@@ -6824,13 +6228,13 @@
               </a:spcAft>
             </a:pPr>
             <a:r>
-              <a:rPr sz="1500" b="0" i="0">
+              <a:rPr sz="1400" b="0">
                 <a:solidFill>
                   <a:srgbClr val="5A5F66"/>
                 </a:solidFill>
                 <a:latin typeface="Calibri"/>
               </a:rPr>
-              <a:t>Primary expected payer by age group, weighted % of visits with a known payer</a:t>
+              <a:t>Primary expected payer by age group, weighted % of visits with a known expected payer (89.2% of visits)</a:t>
             </a:r>
           </a:p>
         </p:txBody>
@@ -6844,8 +6248,8 @@
           <p:nvPr/>
         </p:nvGraphicFramePr>
         <p:xfrm>
-          <a:off x="457200" y="1554480"/>
-          <a:ext cx="7589520" cy="4846320"/>
+          <a:off x="457200" y="1783080"/>
+          <a:ext cx="7680960" cy="4754880"/>
         </p:xfrm>
         <a:graphic>
           <a:graphicData uri="http://schemas.openxmlformats.org/drawingml/2006/chart">
@@ -6855,60 +6259,14 @@
       </p:graphicFrame>
       <p:sp>
         <p:nvSpPr>
-          <p:cNvPr id="5" name="Rounded Rectangle 4"/>
-          <p:cNvSpPr/>
+          <p:cNvPr id="5" name="TextBox 4"/>
+          <p:cNvSpPr txBox="1"/>
           <p:nvPr/>
         </p:nvSpPr>
         <p:spPr>
           <a:xfrm>
-            <a:off x="8412480" y="1600200"/>
-            <a:ext cx="3291840" cy="1417320"/>
-          </a:xfrm>
-          <a:prstGeom prst="roundRect">
-            <a:avLst>
-              <a:gd name="adj" fmla="val 8000"/>
-            </a:avLst>
-          </a:prstGeom>
-          <a:solidFill>
-            <a:srgbClr val="ECF1F7"/>
-          </a:solidFill>
-          <a:ln>
-            <a:noFill/>
-          </a:ln>
-          <a:effectLst/>
-        </p:spPr>
-        <p:style>
-          <a:lnRef idx="1">
-            <a:schemeClr val="accent1"/>
-          </a:lnRef>
-          <a:fillRef idx="3">
-            <a:schemeClr val="accent1"/>
-          </a:fillRef>
-          <a:effectRef idx="2">
-            <a:schemeClr val="accent1"/>
-          </a:effectRef>
-          <a:fontRef idx="minor">
-            <a:schemeClr val="lt1"/>
-          </a:fontRef>
-        </p:style>
-        <p:txBody>
-          <a:bodyPr rtlCol="0" anchor="ctr"/>
-          <a:lstStyle/>
-          <a:p>
-            <a:pPr algn="ctr"/>
-          </a:p>
-        </p:txBody>
-      </p:sp>
-      <p:sp>
-        <p:nvSpPr>
-          <p:cNvPr id="6" name="TextBox 5"/>
-          <p:cNvSpPr txBox="1"/>
-          <p:nvPr/>
-        </p:nvSpPr>
-        <p:spPr>
-          <a:xfrm>
-            <a:off x="8641080" y="1764792"/>
-            <a:ext cx="2834640" cy="685800"/>
+            <a:off x="8595360" y="1920240"/>
+            <a:ext cx="3108960" cy="685800"/>
           </a:xfrm>
           <a:prstGeom prst="rect">
             <a:avLst/>
@@ -6927,27 +6285,27 @@
               </a:spcAft>
             </a:pPr>
             <a:r>
-              <a:rPr sz="3400" b="1" i="0">
+              <a:rPr sz="3800" b="1">
                 <a:solidFill>
                   <a:srgbClr val="16324F"/>
                 </a:solidFill>
                 <a:latin typeface="Cambria"/>
               </a:rPr>
-              <a:t>54.8%</a:t>
-            </a:r>
-          </a:p>
-        </p:txBody>
-      </p:sp>
-      <p:sp>
-        <p:nvSpPr>
-          <p:cNvPr id="7" name="TextBox 6"/>
+              <a:t>48.9%</a:t>
+            </a:r>
+          </a:p>
+        </p:txBody>
+      </p:sp>
+      <p:sp>
+        <p:nvSpPr>
+          <p:cNvPr id="6" name="TextBox 5"/>
           <p:cNvSpPr txBox="1"/>
           <p:nvPr/>
         </p:nvSpPr>
         <p:spPr>
           <a:xfrm>
-            <a:off x="8641080" y="2441448"/>
-            <a:ext cx="2834640" cy="502920"/>
+            <a:off x="8595360" y="2578608"/>
+            <a:ext cx="3108960" cy="822960"/>
           </a:xfrm>
           <a:prstGeom prst="rect">
             <a:avLst/>
@@ -6966,73 +6324,27 @@
               </a:spcAft>
             </a:pPr>
             <a:r>
-              <a:rPr sz="1250" b="0" i="0">
+              <a:rPr sz="1300" b="0">
                 <a:solidFill>
                   <a:srgbClr val="5A5F66"/>
                 </a:solidFill>
                 <a:latin typeface="Calibri"/>
               </a:rPr>
-              <a:t>of known-payer visits paid by Medicaid (34.9%) or Medicare (19.9%)</a:t>
-            </a:r>
-          </a:p>
-        </p:txBody>
-      </p:sp>
-      <p:sp>
-        <p:nvSpPr>
-          <p:cNvPr id="8" name="Rounded Rectangle 7"/>
-          <p:cNvSpPr/>
+              <a:t>of all visits list Medicaid or Medicare as primary expected payer (54.8% of visits with a known payer)</a:t>
+            </a:r>
+          </a:p>
+        </p:txBody>
+      </p:sp>
+      <p:sp>
+        <p:nvSpPr>
+          <p:cNvPr id="7" name="TextBox 6"/>
+          <p:cNvSpPr txBox="1"/>
           <p:nvPr/>
         </p:nvSpPr>
         <p:spPr>
           <a:xfrm>
-            <a:off x="8412480" y="3200400"/>
-            <a:ext cx="3291840" cy="1417320"/>
-          </a:xfrm>
-          <a:prstGeom prst="roundRect">
-            <a:avLst>
-              <a:gd name="adj" fmla="val 8000"/>
-            </a:avLst>
-          </a:prstGeom>
-          <a:solidFill>
-            <a:srgbClr val="ECF1F7"/>
-          </a:solidFill>
-          <a:ln>
-            <a:noFill/>
-          </a:ln>
-          <a:effectLst/>
-        </p:spPr>
-        <p:style>
-          <a:lnRef idx="1">
-            <a:schemeClr val="accent1"/>
-          </a:lnRef>
-          <a:fillRef idx="3">
-            <a:schemeClr val="accent1"/>
-          </a:fillRef>
-          <a:effectRef idx="2">
-            <a:schemeClr val="accent1"/>
-          </a:effectRef>
-          <a:fontRef idx="minor">
-            <a:schemeClr val="lt1"/>
-          </a:fontRef>
-        </p:style>
-        <p:txBody>
-          <a:bodyPr rtlCol="0" anchor="ctr"/>
-          <a:lstStyle/>
-          <a:p>
-            <a:pPr algn="ctr"/>
-          </a:p>
-        </p:txBody>
-      </p:sp>
-      <p:sp>
-        <p:nvSpPr>
-          <p:cNvPr id="9" name="TextBox 8"/>
-          <p:cNvSpPr txBox="1"/>
-          <p:nvPr/>
-        </p:nvSpPr>
-        <p:spPr>
-          <a:xfrm>
-            <a:off x="8641080" y="3364992"/>
-            <a:ext cx="2834640" cy="685800"/>
+            <a:off x="8595360" y="3474720"/>
+            <a:ext cx="3108960" cy="685800"/>
           </a:xfrm>
           <a:prstGeom prst="rect">
             <a:avLst/>
@@ -7051,7 +6363,7 @@
               </a:spcAft>
             </a:pPr>
             <a:r>
-              <a:rPr sz="3400" b="1" i="0">
+              <a:rPr sz="3800" b="1">
                 <a:solidFill>
                   <a:srgbClr val="EB6834"/>
                 </a:solidFill>
@@ -7064,14 +6376,14 @@
       </p:sp>
       <p:sp>
         <p:nvSpPr>
-          <p:cNvPr id="10" name="TextBox 9"/>
+          <p:cNvPr id="8" name="TextBox 7"/>
           <p:cNvSpPr txBox="1"/>
           <p:nvPr/>
         </p:nvSpPr>
         <p:spPr>
           <a:xfrm>
-            <a:off x="8641080" y="4041648"/>
-            <a:ext cx="2834640" cy="502920"/>
+            <a:off x="8595360" y="4133087"/>
+            <a:ext cx="3108960" cy="822960"/>
           </a:xfrm>
           <a:prstGeom prst="rect">
             <a:avLst/>
@@ -7090,73 +6402,27 @@
               </a:spcAft>
             </a:pPr>
             <a:r>
-              <a:rPr sz="1250" b="0" i="0">
+              <a:rPr sz="1300" b="0">
                 <a:solidFill>
                   <a:srgbClr val="5A5F66"/>
                 </a:solidFill>
                 <a:latin typeface="Calibri"/>
               </a:rPr>
-              <a:t>self-pay or charity care; EDs must treat regardless (EMTALA)</a:t>
-            </a:r>
-          </a:p>
-        </p:txBody>
-      </p:sp>
-      <p:sp>
-        <p:nvSpPr>
-          <p:cNvPr id="11" name="Rounded Rectangle 10"/>
-          <p:cNvSpPr/>
+              <a:t>self-pay or no charge (visits with a known payer)</a:t>
+            </a:r>
+          </a:p>
+        </p:txBody>
+      </p:sp>
+      <p:sp>
+        <p:nvSpPr>
+          <p:cNvPr id="9" name="TextBox 8"/>
+          <p:cNvSpPr txBox="1"/>
           <p:nvPr/>
         </p:nvSpPr>
         <p:spPr>
           <a:xfrm>
-            <a:off x="8412480" y="4800600"/>
-            <a:ext cx="3291840" cy="1508760"/>
-          </a:xfrm>
-          <a:prstGeom prst="roundRect">
-            <a:avLst>
-              <a:gd name="adj" fmla="val 8000"/>
-            </a:avLst>
-          </a:prstGeom>
-          <a:solidFill>
-            <a:srgbClr val="ECF1F7"/>
-          </a:solidFill>
-          <a:ln>
-            <a:noFill/>
-          </a:ln>
-          <a:effectLst/>
-        </p:spPr>
-        <p:style>
-          <a:lnRef idx="1">
-            <a:schemeClr val="accent1"/>
-          </a:lnRef>
-          <a:fillRef idx="3">
-            <a:schemeClr val="accent1"/>
-          </a:fillRef>
-          <a:effectRef idx="2">
-            <a:schemeClr val="accent1"/>
-          </a:effectRef>
-          <a:fontRef idx="minor">
-            <a:schemeClr val="lt1"/>
-          </a:fontRef>
-        </p:style>
-        <p:txBody>
-          <a:bodyPr rtlCol="0" anchor="ctr"/>
-          <a:lstStyle/>
-          <a:p>
-            <a:pPr algn="ctr"/>
-          </a:p>
-        </p:txBody>
-      </p:sp>
-      <p:sp>
-        <p:nvSpPr>
-          <p:cNvPr id="12" name="TextBox 11"/>
-          <p:cNvSpPr txBox="1"/>
-          <p:nvPr/>
-        </p:nvSpPr>
-        <p:spPr>
-          <a:xfrm>
-            <a:off x="8641080" y="4937760"/>
-            <a:ext cx="2834640" cy="1280160"/>
+            <a:off x="8595360" y="4800600"/>
+            <a:ext cx="3108960" cy="1645920"/>
           </a:xfrm>
           <a:prstGeom prst="rect">
             <a:avLst/>
@@ -7175,29 +6441,13 @@
               </a:spcAft>
             </a:pPr>
             <a:r>
-              <a:rPr sz="1300" b="1" i="0">
-                <a:solidFill>
-                  <a:srgbClr val="16324F"/>
-                </a:solidFill>
-                <a:latin typeface="Calibri"/>
-              </a:rPr>
-              <a:t>Margin pressure</a:t>
-            </a:r>
-          </a:p>
-          <a:p>
-            <a:pPr algn="l">
-              <a:spcAft>
-                <a:spcPts val="600"/>
-              </a:spcAft>
-            </a:pPr>
-            <a:r>
-              <a:rPr sz="1200" b="0" i="0">
+              <a:rPr sz="1300" b="0">
                 <a:solidFill>
                   <a:srgbClr val="1A1A1A"/>
                 </a:solidFill>
                 <a:latin typeface="Calibri"/>
               </a:rPr>
-              <a:t>Private insurance (30.9%) cross-subsidizes. 10.8% of visits have no recorded payer, a revenue-cycle gap.</a:t>
+              <a:t>Expected payer is not revenue. If public programs pay less per visit than private insurers, this mix limits per-visit revenue; the actual effect depends on contracts and collections.</a:t>
             </a:r>
           </a:p>
         </p:txBody>
@@ -7236,8 +6486,8 @@
         </p:nvSpPr>
         <p:spPr>
           <a:xfrm>
-            <a:off x="548640" y="365760"/>
-            <a:ext cx="11064240" cy="731520"/>
+            <a:off x="548640" y="320040"/>
+            <a:ext cx="11064240" cy="914400"/>
           </a:xfrm>
           <a:prstGeom prst="rect">
             <a:avLst/>
@@ -7256,73 +6506,27 @@
               </a:spcAft>
             </a:pPr>
             <a:r>
-              <a:rPr sz="3000" b="1" i="0">
+              <a:rPr sz="2600" b="1">
                 <a:solidFill>
                   <a:srgbClr val="16324F"/>
                 </a:solidFill>
                 <a:latin typeface="Cambria"/>
               </a:rPr>
-              <a:t>EDs treat complex patients: chronic disease and injuries</a:t>
-            </a:r>
-          </a:p>
-        </p:txBody>
-      </p:sp>
-      <p:sp>
-        <p:nvSpPr>
-          <p:cNvPr id="3" name="Rounded Rectangle 2"/>
-          <p:cNvSpPr/>
+              <a:t>Diabetes ranks second among chronic conditions once its three checkboxes are combined</a:t>
+            </a:r>
+          </a:p>
+        </p:txBody>
+      </p:sp>
+      <p:sp>
+        <p:nvSpPr>
+          <p:cNvPr id="3" name="TextBox 2"/>
+          <p:cNvSpPr txBox="1"/>
           <p:nvPr/>
         </p:nvSpPr>
         <p:spPr>
           <a:xfrm>
-            <a:off x="548640" y="1234440"/>
-            <a:ext cx="2606040" cy="1463040"/>
-          </a:xfrm>
-          <a:prstGeom prst="roundRect">
-            <a:avLst>
-              <a:gd name="adj" fmla="val 8000"/>
-            </a:avLst>
-          </a:prstGeom>
-          <a:solidFill>
-            <a:srgbClr val="ECF1F7"/>
-          </a:solidFill>
-          <a:ln>
-            <a:noFill/>
-          </a:ln>
-          <a:effectLst/>
-        </p:spPr>
-        <p:style>
-          <a:lnRef idx="1">
-            <a:schemeClr val="accent1"/>
-          </a:lnRef>
-          <a:fillRef idx="3">
-            <a:schemeClr val="accent1"/>
-          </a:fillRef>
-          <a:effectRef idx="2">
-            <a:schemeClr val="accent1"/>
-          </a:effectRef>
-          <a:fontRef idx="minor">
-            <a:schemeClr val="lt1"/>
-          </a:fontRef>
-        </p:style>
-        <p:txBody>
-          <a:bodyPr rtlCol="0" anchor="ctr"/>
-          <a:lstStyle/>
-          <a:p>
-            <a:pPr algn="ctr"/>
-          </a:p>
-        </p:txBody>
-      </p:sp>
-      <p:sp>
-        <p:nvSpPr>
-          <p:cNvPr id="4" name="TextBox 3"/>
-          <p:cNvSpPr txBox="1"/>
-          <p:nvPr/>
-        </p:nvSpPr>
-        <p:spPr>
-          <a:xfrm>
-            <a:off x="777240" y="1399032"/>
-            <a:ext cx="2148840" cy="685800"/>
+            <a:off x="548640" y="1261872"/>
+            <a:ext cx="11064240" cy="365760"/>
           </a:xfrm>
           <a:prstGeom prst="rect">
             <a:avLst/>
@@ -7341,439 +6545,28 @@
               </a:spcAft>
             </a:pPr>
             <a:r>
-              <a:rPr sz="3400" b="1" i="0">
-                <a:solidFill>
-                  <a:srgbClr val="16324F"/>
-                </a:solidFill>
-                <a:latin typeface="Cambria"/>
-              </a:rPr>
-              <a:t>47.6%</a:t>
-            </a:r>
-          </a:p>
-        </p:txBody>
-      </p:sp>
-      <p:sp>
-        <p:nvSpPr>
-          <p:cNvPr id="5" name="TextBox 4"/>
-          <p:cNvSpPr txBox="1"/>
-          <p:nvPr/>
-        </p:nvSpPr>
-        <p:spPr>
-          <a:xfrm>
-            <a:off x="777240" y="2075688"/>
-            <a:ext cx="2148840" cy="548640"/>
-          </a:xfrm>
-          <a:prstGeom prst="rect">
-            <a:avLst/>
-          </a:prstGeom>
-          <a:noFill/>
-        </p:spPr>
-        <p:txBody>
-          <a:bodyPr wrap="square" anchor="t" lIns="0" rIns="0" tIns="0" bIns="0">
-            <a:spAutoFit/>
-          </a:bodyPr>
-          <a:lstStyle/>
-          <a:p>
-            <a:pPr algn="l">
-              <a:spcAft>
-                <a:spcPts val="600"/>
-              </a:spcAft>
-            </a:pPr>
-            <a:r>
-              <a:rPr sz="1250" b="0" i="0">
+              <a:rPr sz="1400" b="0">
                 <a:solidFill>
                   <a:srgbClr val="5A5F66"/>
                 </a:solidFill>
                 <a:latin typeface="Calibri"/>
               </a:rPr>
-              <a:t>visits with 1+ chronic condition (90% at 75+)</a:t>
-            </a:r>
-          </a:p>
-        </p:txBody>
-      </p:sp>
-      <p:sp>
-        <p:nvSpPr>
-          <p:cNvPr id="6" name="Rounded Rectangle 5"/>
-          <p:cNvSpPr/>
-          <p:nvPr/>
-        </p:nvSpPr>
-        <p:spPr>
-          <a:xfrm>
-            <a:off x="3383280" y="1234440"/>
-            <a:ext cx="2606040" cy="1463040"/>
-          </a:xfrm>
-          <a:prstGeom prst="roundRect">
-            <a:avLst>
-              <a:gd name="adj" fmla="val 8000"/>
-            </a:avLst>
-          </a:prstGeom>
-          <a:solidFill>
-            <a:srgbClr val="ECF1F7"/>
-          </a:solidFill>
-          <a:ln>
-            <a:noFill/>
-          </a:ln>
-          <a:effectLst/>
-        </p:spPr>
-        <p:style>
-          <a:lnRef idx="1">
-            <a:schemeClr val="accent1"/>
-          </a:lnRef>
-          <a:fillRef idx="3">
-            <a:schemeClr val="accent1"/>
-          </a:fillRef>
-          <a:effectRef idx="2">
-            <a:schemeClr val="accent1"/>
-          </a:effectRef>
-          <a:fontRef idx="minor">
-            <a:schemeClr val="lt1"/>
-          </a:fontRef>
-        </p:style>
-        <p:txBody>
-          <a:bodyPr rtlCol="0" anchor="ctr"/>
-          <a:lstStyle/>
-          <a:p>
-            <a:pPr algn="ctr"/>
-          </a:p>
-        </p:txBody>
-      </p:sp>
-      <p:sp>
-        <p:nvSpPr>
-          <p:cNvPr id="7" name="TextBox 6"/>
-          <p:cNvSpPr txBox="1"/>
-          <p:nvPr/>
-        </p:nvSpPr>
-        <p:spPr>
-          <a:xfrm>
-            <a:off x="3611880" y="1399032"/>
-            <a:ext cx="2148840" cy="685800"/>
-          </a:xfrm>
-          <a:prstGeom prst="rect">
-            <a:avLst/>
-          </a:prstGeom>
-          <a:noFill/>
-        </p:spPr>
-        <p:txBody>
-          <a:bodyPr wrap="square" anchor="t" lIns="0" rIns="0" tIns="0" bIns="0">
-            <a:spAutoFit/>
-          </a:bodyPr>
-          <a:lstStyle/>
-          <a:p>
-            <a:pPr algn="l">
-              <a:spcAft>
-                <a:spcPts val="600"/>
-              </a:spcAft>
-            </a:pPr>
-            <a:r>
-              <a:rPr sz="3400" b="1" i="0">
-                <a:solidFill>
-                  <a:srgbClr val="16324F"/>
-                </a:solidFill>
-                <a:latin typeface="Cambria"/>
-              </a:rPr>
-              <a:t>33.1%</a:t>
-            </a:r>
-          </a:p>
-        </p:txBody>
-      </p:sp>
-      <p:sp>
-        <p:nvSpPr>
-          <p:cNvPr id="8" name="TextBox 7"/>
-          <p:cNvSpPr txBox="1"/>
-          <p:nvPr/>
-        </p:nvSpPr>
-        <p:spPr>
-          <a:xfrm>
-            <a:off x="3611880" y="2075688"/>
-            <a:ext cx="2148840" cy="548640"/>
-          </a:xfrm>
-          <a:prstGeom prst="rect">
-            <a:avLst/>
-          </a:prstGeom>
-          <a:noFill/>
-        </p:spPr>
-        <p:txBody>
-          <a:bodyPr wrap="square" anchor="t" lIns="0" rIns="0" tIns="0" bIns="0">
-            <a:spAutoFit/>
-          </a:bodyPr>
-          <a:lstStyle/>
-          <a:p>
-            <a:pPr algn="l">
-              <a:spcAft>
-                <a:spcPts val="600"/>
-              </a:spcAft>
-            </a:pPr>
-            <a:r>
-              <a:rPr sz="1250" b="0" i="0">
-                <a:solidFill>
-                  <a:srgbClr val="5A5F66"/>
-                </a:solidFill>
-                <a:latin typeface="Calibri"/>
-              </a:rPr>
-              <a:t>injury, overdose or adverse-effect visits (7.3% intentional)</a:t>
-            </a:r>
-          </a:p>
-        </p:txBody>
-      </p:sp>
-      <p:sp>
-        <p:nvSpPr>
-          <p:cNvPr id="9" name="Rounded Rectangle 8"/>
-          <p:cNvSpPr/>
-          <p:nvPr/>
-        </p:nvSpPr>
-        <p:spPr>
-          <a:xfrm>
-            <a:off x="6217920" y="1234440"/>
-            <a:ext cx="2606040" cy="1463040"/>
-          </a:xfrm>
-          <a:prstGeom prst="roundRect">
-            <a:avLst>
-              <a:gd name="adj" fmla="val 8000"/>
-            </a:avLst>
-          </a:prstGeom>
-          <a:solidFill>
-            <a:srgbClr val="ECF1F7"/>
-          </a:solidFill>
-          <a:ln>
-            <a:noFill/>
-          </a:ln>
-          <a:effectLst/>
-        </p:spPr>
-        <p:style>
-          <a:lnRef idx="1">
-            <a:schemeClr val="accent1"/>
-          </a:lnRef>
-          <a:fillRef idx="3">
-            <a:schemeClr val="accent1"/>
-          </a:fillRef>
-          <a:effectRef idx="2">
-            <a:schemeClr val="accent1"/>
-          </a:effectRef>
-          <a:fontRef idx="minor">
-            <a:schemeClr val="lt1"/>
-          </a:fontRef>
-        </p:style>
-        <p:txBody>
-          <a:bodyPr rtlCol="0" anchor="ctr"/>
-          <a:lstStyle/>
-          <a:p>
-            <a:pPr algn="ctr"/>
-          </a:p>
-        </p:txBody>
-      </p:sp>
-      <p:sp>
-        <p:nvSpPr>
-          <p:cNvPr id="10" name="TextBox 9"/>
-          <p:cNvSpPr txBox="1"/>
-          <p:nvPr/>
-        </p:nvSpPr>
-        <p:spPr>
-          <a:xfrm>
-            <a:off x="6446520" y="1399032"/>
-            <a:ext cx="2148840" cy="685800"/>
-          </a:xfrm>
-          <a:prstGeom prst="rect">
-            <a:avLst/>
-          </a:prstGeom>
-          <a:noFill/>
-        </p:spPr>
-        <p:txBody>
-          <a:bodyPr wrap="square" anchor="t" lIns="0" rIns="0" tIns="0" bIns="0">
-            <a:spAutoFit/>
-          </a:bodyPr>
-          <a:lstStyle/>
-          <a:p>
-            <a:pPr algn="l">
-              <a:spcAft>
-                <a:spcPts val="600"/>
-              </a:spcAft>
-            </a:pPr>
-            <a:r>
-              <a:rPr sz="3400" b="1" i="0">
-                <a:solidFill>
-                  <a:srgbClr val="16324F"/>
-                </a:solidFill>
-                <a:latin typeface="Cambria"/>
-              </a:rPr>
-              <a:t>47.0%</a:t>
-            </a:r>
-          </a:p>
-        </p:txBody>
-      </p:sp>
-      <p:sp>
-        <p:nvSpPr>
-          <p:cNvPr id="11" name="TextBox 10"/>
-          <p:cNvSpPr txBox="1"/>
-          <p:nvPr/>
-        </p:nvSpPr>
-        <p:spPr>
-          <a:xfrm>
-            <a:off x="6446520" y="2075688"/>
-            <a:ext cx="2148840" cy="548640"/>
-          </a:xfrm>
-          <a:prstGeom prst="rect">
-            <a:avLst/>
-          </a:prstGeom>
-          <a:noFill/>
-        </p:spPr>
-        <p:txBody>
-          <a:bodyPr wrap="square" anchor="t" lIns="0" rIns="0" tIns="0" bIns="0">
-            <a:spAutoFit/>
-          </a:bodyPr>
-          <a:lstStyle/>
-          <a:p>
-            <a:pPr algn="l">
-              <a:spcAft>
-                <a:spcPts val="600"/>
-              </a:spcAft>
-            </a:pPr>
-            <a:r>
-              <a:rPr sz="1250" b="0" i="0">
-                <a:solidFill>
-                  <a:srgbClr val="5A5F66"/>
-                </a:solidFill>
-                <a:latin typeface="Calibri"/>
-              </a:rPr>
-              <a:t>visits with imaging; 42.4% with a blood test (CBC in 85%)</a:t>
-            </a:r>
-          </a:p>
-        </p:txBody>
-      </p:sp>
-      <p:sp>
-        <p:nvSpPr>
-          <p:cNvPr id="12" name="Rounded Rectangle 11"/>
-          <p:cNvSpPr/>
-          <p:nvPr/>
-        </p:nvSpPr>
-        <p:spPr>
-          <a:xfrm>
-            <a:off x="9052560" y="1234440"/>
-            <a:ext cx="2606040" cy="1463040"/>
-          </a:xfrm>
-          <a:prstGeom prst="roundRect">
-            <a:avLst>
-              <a:gd name="adj" fmla="val 8000"/>
-            </a:avLst>
-          </a:prstGeom>
-          <a:solidFill>
-            <a:srgbClr val="ECF1F7"/>
-          </a:solidFill>
-          <a:ln>
-            <a:noFill/>
-          </a:ln>
-          <a:effectLst/>
-        </p:spPr>
-        <p:style>
-          <a:lnRef idx="1">
-            <a:schemeClr val="accent1"/>
-          </a:lnRef>
-          <a:fillRef idx="3">
-            <a:schemeClr val="accent1"/>
-          </a:fillRef>
-          <a:effectRef idx="2">
-            <a:schemeClr val="accent1"/>
-          </a:effectRef>
-          <a:fontRef idx="minor">
-            <a:schemeClr val="lt1"/>
-          </a:fontRef>
-        </p:style>
-        <p:txBody>
-          <a:bodyPr rtlCol="0" anchor="ctr"/>
-          <a:lstStyle/>
-          <a:p>
-            <a:pPr algn="ctr"/>
-          </a:p>
-        </p:txBody>
-      </p:sp>
-      <p:sp>
-        <p:nvSpPr>
-          <p:cNvPr id="13" name="TextBox 12"/>
-          <p:cNvSpPr txBox="1"/>
-          <p:nvPr/>
-        </p:nvSpPr>
-        <p:spPr>
-          <a:xfrm>
-            <a:off x="9281160" y="1399032"/>
-            <a:ext cx="2148840" cy="685800"/>
-          </a:xfrm>
-          <a:prstGeom prst="rect">
-            <a:avLst/>
-          </a:prstGeom>
-          <a:noFill/>
-        </p:spPr>
-        <p:txBody>
-          <a:bodyPr wrap="square" anchor="t" lIns="0" rIns="0" tIns="0" bIns="0">
-            <a:spAutoFit/>
-          </a:bodyPr>
-          <a:lstStyle/>
-          <a:p>
-            <a:pPr algn="l">
-              <a:spcAft>
-                <a:spcPts val="600"/>
-              </a:spcAft>
-            </a:pPr>
-            <a:r>
-              <a:rPr sz="3400" b="1" i="0">
-                <a:solidFill>
-                  <a:srgbClr val="EB6834"/>
-                </a:solidFill>
-                <a:latin typeface="Cambria"/>
-              </a:rPr>
-              <a:t>37.2%</a:t>
-            </a:r>
-          </a:p>
-        </p:txBody>
-      </p:sp>
-      <p:sp>
-        <p:nvSpPr>
-          <p:cNvPr id="14" name="TextBox 13"/>
-          <p:cNvSpPr txBox="1"/>
-          <p:nvPr/>
-        </p:nvSpPr>
-        <p:spPr>
-          <a:xfrm>
-            <a:off x="9281160" y="2075688"/>
-            <a:ext cx="2148840" cy="548640"/>
-          </a:xfrm>
-          <a:prstGeom prst="rect">
-            <a:avLst/>
-          </a:prstGeom>
-          <a:noFill/>
-        </p:spPr>
-        <p:txBody>
-          <a:bodyPr wrap="square" anchor="t" lIns="0" rIns="0" tIns="0" bIns="0">
-            <a:spAutoFit/>
-          </a:bodyPr>
-          <a:lstStyle/>
-          <a:p>
-            <a:pPr algn="l">
-              <a:spcAft>
-                <a:spcPts val="600"/>
-              </a:spcAft>
-            </a:pPr>
-            <a:r>
-              <a:rPr sz="1250" b="0" i="0">
-                <a:solidFill>
-                  <a:srgbClr val="5A5F66"/>
-                </a:solidFill>
-                <a:latin typeface="Calibri"/>
-              </a:rPr>
-              <a:t>visits with 3+ medications (mean 2.49, median 2)</a:t>
+              <a:t>Weighted % of visits with the chronic-condition section completed (98.4% of records)</a:t>
             </a:r>
           </a:p>
         </p:txBody>
       </p:sp>
       <p:graphicFrame>
         <p:nvGraphicFramePr>
-          <p:cNvPr id="15" name="Chart 14"/>
+          <p:cNvPr id="4" name="Chart 3"/>
           <p:cNvGraphicFramePr>
             <a:graphicFrameLocks noGrp="1"/>
           </p:cNvGraphicFramePr>
           <p:nvPr/>
         </p:nvGraphicFramePr>
         <p:xfrm>
-          <a:off x="457200" y="2971800"/>
-          <a:ext cx="7589520" cy="3520440"/>
+          <a:off x="457200" y="1783080"/>
+          <a:ext cx="7680960" cy="4663440"/>
         </p:xfrm>
         <a:graphic>
           <a:graphicData uri="http://schemas.openxmlformats.org/drawingml/2006/chart">
@@ -7783,60 +6576,14 @@
       </p:graphicFrame>
       <p:sp>
         <p:nvSpPr>
-          <p:cNvPr id="16" name="Rounded Rectangle 15"/>
-          <p:cNvSpPr/>
+          <p:cNvPr id="5" name="TextBox 4"/>
+          <p:cNvSpPr txBox="1"/>
           <p:nvPr/>
         </p:nvSpPr>
         <p:spPr>
           <a:xfrm>
-            <a:off x="8412480" y="3108960"/>
-            <a:ext cx="3291840" cy="3291840"/>
-          </a:xfrm>
-          <a:prstGeom prst="roundRect">
-            <a:avLst>
-              <a:gd name="adj" fmla="val 8000"/>
-            </a:avLst>
-          </a:prstGeom>
-          <a:solidFill>
-            <a:srgbClr val="ECF1F7"/>
-          </a:solidFill>
-          <a:ln>
-            <a:noFill/>
-          </a:ln>
-          <a:effectLst/>
-        </p:spPr>
-        <p:style>
-          <a:lnRef idx="1">
-            <a:schemeClr val="accent1"/>
-          </a:lnRef>
-          <a:fillRef idx="3">
-            <a:schemeClr val="accent1"/>
-          </a:fillRef>
-          <a:effectRef idx="2">
-            <a:schemeClr val="accent1"/>
-          </a:effectRef>
-          <a:fontRef idx="minor">
-            <a:schemeClr val="lt1"/>
-          </a:fontRef>
-        </p:style>
-        <p:txBody>
-          <a:bodyPr rtlCol="0" anchor="ctr"/>
-          <a:lstStyle/>
-          <a:p>
-            <a:pPr algn="ctr"/>
-          </a:p>
-        </p:txBody>
-      </p:sp>
-      <p:sp>
-        <p:nvSpPr>
-          <p:cNvPr id="17" name="TextBox 16"/>
-          <p:cNvSpPr txBox="1"/>
-          <p:nvPr/>
-        </p:nvSpPr>
-        <p:spPr>
-          <a:xfrm>
-            <a:off x="8641080" y="3291840"/>
-            <a:ext cx="2834640" cy="3017520"/>
+            <a:off x="8595360" y="1920240"/>
+            <a:ext cx="3108960" cy="685800"/>
           </a:xfrm>
           <a:prstGeom prst="rect">
             <a:avLst/>
@@ -7855,15 +6602,38 @@
               </a:spcAft>
             </a:pPr>
             <a:r>
-              <a:rPr sz="1300" b="1" i="0">
+              <a:rPr sz="3800" b="1">
                 <a:solidFill>
-                  <a:srgbClr val="16324F"/>
+                  <a:srgbClr val="EB6834"/>
                 </a:solidFill>
-                <a:latin typeface="Calibri"/>
+                <a:latin typeface="Cambria"/>
               </a:rPr>
-              <a:t>What it means</a:t>
-            </a:r>
-          </a:p>
+              <a:t>4.7%</a:t>
+            </a:r>
+          </a:p>
+        </p:txBody>
+      </p:sp>
+      <p:sp>
+        <p:nvSpPr>
+          <p:cNvPr id="6" name="TextBox 5"/>
+          <p:cNvSpPr txBox="1"/>
+          <p:nvPr/>
+        </p:nvSpPr>
+        <p:spPr>
+          <a:xfrm>
+            <a:off x="8595360" y="2578608"/>
+            <a:ext cx="3108960" cy="822960"/>
+          </a:xfrm>
+          <a:prstGeom prst="rect">
+            <a:avLst/>
+          </a:prstGeom>
+          <a:noFill/>
+        </p:spPr>
+        <p:txBody>
+          <a:bodyPr wrap="square" anchor="t" lIns="0" rIns="0" tIns="0" bIns="0">
+            <a:spAutoFit/>
+          </a:bodyPr>
+          <a:lstStyle/>
           <a:p>
             <a:pPr algn="l">
               <a:spcAft>
@@ -7871,15 +6641,38 @@
               </a:spcAft>
             </a:pPr>
             <a:r>
-              <a:rPr sz="1200" b="0" i="0">
+              <a:rPr sz="1300" b="0">
                 <a:solidFill>
-                  <a:srgbClr val="1A1A1A"/>
+                  <a:srgbClr val="5A5F66"/>
                 </a:solidFill>
                 <a:latin typeface="Calibri"/>
               </a:rPr>
-              <a:t>EDs act as a front line for chronic disease: care coordination and follow-up referrals could move avoidable visits to cheaper settings.</a:t>
-            </a:r>
-          </a:p>
+              <a:t>type 2 diabetes alone; combining all three checkboxes gives 11.1%</a:t>
+            </a:r>
+          </a:p>
+        </p:txBody>
+      </p:sp>
+      <p:sp>
+        <p:nvSpPr>
+          <p:cNvPr id="7" name="TextBox 6"/>
+          <p:cNvSpPr txBox="1"/>
+          <p:nvPr/>
+        </p:nvSpPr>
+        <p:spPr>
+          <a:xfrm>
+            <a:off x="8595360" y="3337560"/>
+            <a:ext cx="3108960" cy="685800"/>
+          </a:xfrm>
+          <a:prstGeom prst="rect">
+            <a:avLst/>
+          </a:prstGeom>
+          <a:noFill/>
+        </p:spPr>
+        <p:txBody>
+          <a:bodyPr wrap="square" anchor="t" lIns="0" rIns="0" tIns="0" bIns="0">
+            <a:spAutoFit/>
+          </a:bodyPr>
+          <a:lstStyle/>
           <a:p>
             <a:pPr algn="l">
               <a:spcAft>
@@ -7887,15 +6680,38 @@
               </a:spcAft>
             </a:pPr>
             <a:r>
-              <a:rPr sz="1200" b="0" i="0">
+              <a:rPr sz="3800" b="1">
                 <a:solidFill>
-                  <a:srgbClr val="1A1A1A"/>
+                  <a:srgbClr val="16324F"/>
                 </a:solidFill>
-                <a:latin typeface="Calibri"/>
+                <a:latin typeface="Cambria"/>
               </a:rPr>
-              <a:t>Diabetes is split across three checkboxes; combined it is the #2 condition, not #9.</a:t>
-            </a:r>
-          </a:p>
+              <a:t>47.6%</a:t>
+            </a:r>
+          </a:p>
+        </p:txBody>
+      </p:sp>
+      <p:sp>
+        <p:nvSpPr>
+          <p:cNvPr id="8" name="TextBox 7"/>
+          <p:cNvSpPr txBox="1"/>
+          <p:nvPr/>
+        </p:nvSpPr>
+        <p:spPr>
+          <a:xfrm>
+            <a:off x="8595360" y="3995928"/>
+            <a:ext cx="3108960" cy="822960"/>
+          </a:xfrm>
+          <a:prstGeom prst="rect">
+            <a:avLst/>
+          </a:prstGeom>
+          <a:noFill/>
+        </p:spPr>
+        <p:txBody>
+          <a:bodyPr wrap="square" anchor="t" lIns="0" rIns="0" tIns="0" bIns="0">
+            <a:spAutoFit/>
+          </a:bodyPr>
+          <a:lstStyle/>
           <a:p>
             <a:pPr algn="l">
               <a:spcAft>
@@ -7903,13 +6719,91 @@
               </a:spcAft>
             </a:pPr>
             <a:r>
-              <a:rPr sz="1200" b="0" i="0">
+              <a:rPr sz="1300" b="0">
                 <a:solidFill>
-                  <a:srgbClr val="1A1A1A"/>
+                  <a:srgbClr val="5A5F66"/>
                 </a:solidFill>
                 <a:latin typeface="Calibri"/>
               </a:rPr>
-              <a:t>Intensity follows complexity: imaging rises from 29% of child visits to 70% at 75+, and medications from 2.0 per visit (no chronic condition) to 3.8 (three or more).</a:t>
+              <a:t>record at least one chronic condition (90% at ages 75+)</a:t>
+            </a:r>
+          </a:p>
+        </p:txBody>
+      </p:sp>
+      <p:sp>
+        <p:nvSpPr>
+          <p:cNvPr id="9" name="TextBox 8"/>
+          <p:cNvSpPr txBox="1"/>
+          <p:nvPr/>
+        </p:nvSpPr>
+        <p:spPr>
+          <a:xfrm>
+            <a:off x="8595360" y="4754880"/>
+            <a:ext cx="3108960" cy="685800"/>
+          </a:xfrm>
+          <a:prstGeom prst="rect">
+            <a:avLst/>
+          </a:prstGeom>
+          <a:noFill/>
+        </p:spPr>
+        <p:txBody>
+          <a:bodyPr wrap="square" anchor="t" lIns="0" rIns="0" tIns="0" bIns="0">
+            <a:spAutoFit/>
+          </a:bodyPr>
+          <a:lstStyle/>
+          <a:p>
+            <a:pPr algn="l">
+              <a:spcAft>
+                <a:spcPts val="600"/>
+              </a:spcAft>
+            </a:pPr>
+            <a:r>
+              <a:rPr sz="3800" b="1">
+                <a:solidFill>
+                  <a:srgbClr val="16324F"/>
+                </a:solidFill>
+                <a:latin typeface="Cambria"/>
+              </a:rPr>
+              <a:t>37.2%</a:t>
+            </a:r>
+          </a:p>
+        </p:txBody>
+      </p:sp>
+      <p:sp>
+        <p:nvSpPr>
+          <p:cNvPr id="10" name="TextBox 9"/>
+          <p:cNvSpPr txBox="1"/>
+          <p:nvPr/>
+        </p:nvSpPr>
+        <p:spPr>
+          <a:xfrm>
+            <a:off x="8595360" y="5413248"/>
+            <a:ext cx="3108960" cy="822960"/>
+          </a:xfrm>
+          <a:prstGeom prst="rect">
+            <a:avLst/>
+          </a:prstGeom>
+          <a:noFill/>
+        </p:spPr>
+        <p:txBody>
+          <a:bodyPr wrap="square" anchor="t" lIns="0" rIns="0" tIns="0" bIns="0">
+            <a:spAutoFit/>
+          </a:bodyPr>
+          <a:lstStyle/>
+          <a:p>
+            <a:pPr algn="l">
+              <a:spcAft>
+                <a:spcPts val="600"/>
+              </a:spcAft>
+            </a:pPr>
+            <a:r>
+              <a:rPr sz="1300" b="0">
+                <a:solidFill>
+                  <a:srgbClr val="5A5F66"/>
+                </a:solidFill>
+                <a:latin typeface="Calibri"/>
+              </a:rPr>
+              <a:t>of all visits involve three or more medications (median 2)</a:t>
             </a:r>
           </a:p>
         </p:txBody>
@@ -7948,8 +6842,8 @@
         </p:nvSpPr>
         <p:spPr>
           <a:xfrm>
-            <a:off x="548640" y="365760"/>
-            <a:ext cx="11064240" cy="731520"/>
+            <a:off x="548640" y="320040"/>
+            <a:ext cx="11064240" cy="914400"/>
           </a:xfrm>
           <a:prstGeom prst="rect">
             <a:avLst/>
@@ -7968,13 +6862,13 @@
               </a:spcAft>
             </a:pPr>
             <a:r>
-              <a:rPr sz="3000" b="1" i="0">
+              <a:rPr sz="2600" b="1">
                 <a:solidFill>
                   <a:srgbClr val="FFFFFF"/>
                 </a:solidFill>
                 <a:latin typeface="Cambria"/>
               </a:rPr>
-              <a:t>Triage sorts outcomes sharply, but not waiting times</a:t>
+              <a:t>Triage level tracks admission closely; recorded waits differ little beyond level 1</a:t>
             </a:r>
           </a:p>
         </p:txBody>
@@ -7987,8 +6881,8 @@
         </p:nvSpPr>
         <p:spPr>
           <a:xfrm>
-            <a:off x="548640" y="1024128"/>
-            <a:ext cx="11064240" cy="411480"/>
+            <a:off x="548640" y="1261872"/>
+            <a:ext cx="11064240" cy="365760"/>
           </a:xfrm>
           <a:prstGeom prst="rect">
             <a:avLst/>
@@ -8007,13 +6901,13 @@
               </a:spcAft>
             </a:pPr>
             <a:r>
-              <a:rPr sz="1500" b="0" i="0">
+              <a:rPr sz="1400" b="0">
                 <a:solidFill>
                   <a:srgbClr val="CADCFC"/>
                 </a:solidFill>
                 <a:latin typeface="Calibri"/>
               </a:rPr>
-              <a:t>Weighted, by triage level (1 = immediate ... 5 = nonurgent)</a:t>
+              <a:t>Weighted, visits with triage levels 1-5 (1 = immediate, 5 = nonurgent)</a:t>
             </a:r>
           </a:p>
         </p:txBody>
@@ -8026,12 +6920,12 @@
         </p:nvSpPr>
         <p:spPr>
           <a:xfrm>
-            <a:off x="457200" y="1600200"/>
-            <a:ext cx="3657600" cy="3246120"/>
+            <a:off x="457200" y="1783080"/>
+            <a:ext cx="3703320" cy="3200400"/>
           </a:xfrm>
           <a:prstGeom prst="roundRect">
             <a:avLst>
-              <a:gd name="adj" fmla="val 8000"/>
+              <a:gd name="adj" fmla="val 6000"/>
             </a:avLst>
           </a:prstGeom>
           <a:solidFill>
@@ -8064,17 +6958,56 @@
           </a:p>
         </p:txBody>
       </p:sp>
+      <p:sp>
+        <p:nvSpPr>
+          <p:cNvPr id="5" name="TextBox 4"/>
+          <p:cNvSpPr txBox="1"/>
+          <p:nvPr/>
+        </p:nvSpPr>
+        <p:spPr>
+          <a:xfrm>
+            <a:off x="685800" y="1901952"/>
+            <a:ext cx="3291840" cy="365760"/>
+          </a:xfrm>
+          <a:prstGeom prst="rect">
+            <a:avLst/>
+          </a:prstGeom>
+          <a:noFill/>
+        </p:spPr>
+        <p:txBody>
+          <a:bodyPr wrap="square" anchor="t" lIns="0" rIns="0" tIns="0" bIns="0">
+            <a:spAutoFit/>
+          </a:bodyPr>
+          <a:lstStyle/>
+          <a:p>
+            <a:pPr algn="l">
+              <a:spcAft>
+                <a:spcPts val="600"/>
+              </a:spcAft>
+            </a:pPr>
+            <a:r>
+              <a:rPr sz="1300" b="1">
+                <a:solidFill>
+                  <a:srgbClr val="FFFFFF"/>
+                </a:solidFill>
+                <a:latin typeface="Calibri"/>
+              </a:rPr>
+              <a:t>Admitted to hospital (%)</a:t>
+            </a:r>
+          </a:p>
+        </p:txBody>
+      </p:sp>
       <p:graphicFrame>
         <p:nvGraphicFramePr>
-          <p:cNvPr id="5" name="Chart 4"/>
+          <p:cNvPr id="6" name="Chart 5"/>
           <p:cNvGraphicFramePr>
             <a:graphicFrameLocks noGrp="1"/>
           </p:cNvGraphicFramePr>
           <p:nvPr/>
         </p:nvGraphicFramePr>
         <p:xfrm>
-          <a:off x="548640" y="1691640"/>
-          <a:ext cx="3474720" cy="3063240"/>
+          <a:off x="548640" y="2240280"/>
+          <a:ext cx="3520440" cy="2651760"/>
         </p:xfrm>
         <a:graphic>
           <a:graphicData uri="http://schemas.openxmlformats.org/drawingml/2006/chart">
@@ -8084,18 +7017,18 @@
       </p:graphicFrame>
       <p:sp>
         <p:nvSpPr>
-          <p:cNvPr id="6" name="Rounded Rectangle 5"/>
+          <p:cNvPr id="7" name="Rounded Rectangle 6"/>
           <p:cNvSpPr/>
           <p:nvPr/>
         </p:nvSpPr>
         <p:spPr>
           <a:xfrm>
-            <a:off x="4297680" y="1600200"/>
-            <a:ext cx="3657600" cy="3246120"/>
+            <a:off x="4343400" y="1783080"/>
+            <a:ext cx="3703320" cy="3200400"/>
           </a:xfrm>
           <a:prstGeom prst="roundRect">
             <a:avLst>
-              <a:gd name="adj" fmla="val 8000"/>
+              <a:gd name="adj" fmla="val 6000"/>
             </a:avLst>
           </a:prstGeom>
           <a:solidFill>
@@ -8128,17 +7061,56 @@
           </a:p>
         </p:txBody>
       </p:sp>
+      <p:sp>
+        <p:nvSpPr>
+          <p:cNvPr id="8" name="TextBox 7"/>
+          <p:cNvSpPr txBox="1"/>
+          <p:nvPr/>
+        </p:nvSpPr>
+        <p:spPr>
+          <a:xfrm>
+            <a:off x="4572000" y="1901952"/>
+            <a:ext cx="3291840" cy="365760"/>
+          </a:xfrm>
+          <a:prstGeom prst="rect">
+            <a:avLst/>
+          </a:prstGeom>
+          <a:noFill/>
+        </p:spPr>
+        <p:txBody>
+          <a:bodyPr wrap="square" anchor="t" lIns="0" rIns="0" tIns="0" bIns="0">
+            <a:spAutoFit/>
+          </a:bodyPr>
+          <a:lstStyle/>
+          <a:p>
+            <a:pPr algn="l">
+              <a:spcAft>
+                <a:spcPts val="600"/>
+              </a:spcAft>
+            </a:pPr>
+            <a:r>
+              <a:rPr sz="1300" b="1">
+                <a:solidFill>
+                  <a:srgbClr val="FFFFFF"/>
+                </a:solidFill>
+                <a:latin typeface="Calibri"/>
+              </a:rPr>
+              <a:t>Median recorded wait to see a provider (min)</a:t>
+            </a:r>
+          </a:p>
+        </p:txBody>
+      </p:sp>
       <p:graphicFrame>
         <p:nvGraphicFramePr>
-          <p:cNvPr id="7" name="Chart 6"/>
+          <p:cNvPr id="9" name="Chart 8"/>
           <p:cNvGraphicFramePr>
             <a:graphicFrameLocks noGrp="1"/>
           </p:cNvGraphicFramePr>
           <p:nvPr/>
         </p:nvGraphicFramePr>
         <p:xfrm>
-          <a:off x="4389120" y="1691640"/>
-          <a:ext cx="3474720" cy="3063240"/>
+          <a:off x="4434840" y="2240280"/>
+          <a:ext cx="3520440" cy="2651760"/>
         </p:xfrm>
         <a:graphic>
           <a:graphicData uri="http://schemas.openxmlformats.org/drawingml/2006/chart">
@@ -8148,14 +7120,14 @@
       </p:graphicFrame>
       <p:sp>
         <p:nvSpPr>
-          <p:cNvPr id="8" name="TextBox 7"/>
+          <p:cNvPr id="10" name="TextBox 9"/>
           <p:cNvSpPr txBox="1"/>
           <p:nvPr/>
         </p:nvSpPr>
         <p:spPr>
           <a:xfrm>
-            <a:off x="8229600" y="1600200"/>
-            <a:ext cx="3474720" cy="3291840"/>
+            <a:off x="8366760" y="1828800"/>
+            <a:ext cx="3337560" cy="3200400"/>
           </a:xfrm>
           <a:prstGeom prst="rect">
             <a:avLst/>
@@ -8170,111 +7142,79 @@
           <a:p>
             <a:pPr algn="l">
               <a:spcAft>
-                <a:spcPts val="600"/>
+                <a:spcPts val="900"/>
               </a:spcAft>
             </a:pPr>
             <a:r>
-              <a:rPr sz="1400" b="1" i="0">
+              <a:rPr sz="1400" b="1">
                 <a:solidFill>
                   <a:srgbClr val="FFFFFF"/>
                 </a:solidFill>
                 <a:latin typeface="Calibri"/>
               </a:rPr>
-              <a:t>Correlations (weighted r)</a:t>
+              <a:t>Reading these results</a:t>
             </a:r>
           </a:p>
           <a:p>
             <a:pPr algn="l">
               <a:spcAft>
-                <a:spcPts val="600"/>
+                <a:spcPts val="900"/>
               </a:spcAft>
             </a:pPr>
             <a:r>
-              <a:rPr sz="1250" b="0" i="0">
+              <a:rPr sz="1300" b="0">
                 <a:solidFill>
                   <a:srgbClr val="CADCFC"/>
                 </a:solidFill>
                 <a:latin typeface="Calibri"/>
               </a:rPr>
-              <a:t># blood tests - admitted  0.37</a:t>
+              <a:t>Descriptive, not causal: case mix and hospital differences are not controlled.</a:t>
             </a:r>
           </a:p>
           <a:p>
             <a:pPr algn="l">
               <a:spcAft>
-                <a:spcPts val="600"/>
+                <a:spcPts val="900"/>
               </a:spcAft>
             </a:pPr>
             <a:r>
-              <a:rPr sz="1250" b="0" i="0">
+              <a:rPr sz="1300" b="0">
                 <a:solidFill>
                   <a:srgbClr val="CADCFC"/>
                 </a:solidFill>
                 <a:latin typeface="Calibri"/>
               </a:rPr>
-              <a:t># chronic conditions - admitted  0.33</a:t>
+              <a:t>15% of visits lack a recorded wait, more often where triage was not recorded and in the Northeast and West.</a:t>
             </a:r>
           </a:p>
           <a:p>
             <a:pPr algn="l">
               <a:spcAft>
-                <a:spcPts val="600"/>
+                <a:spcPts val="900"/>
               </a:spcAft>
             </a:pPr>
             <a:r>
-              <a:rPr sz="1250" b="0" i="0">
+              <a:rPr sz="1300" b="0">
                 <a:solidFill>
                   <a:srgbClr val="CADCFC"/>
                 </a:solidFill>
                 <a:latin typeface="Calibri"/>
               </a:rPr>
-              <a:t>Length of visit - # blood tests  0.31</a:t>
-            </a:r>
-          </a:p>
-          <a:p>
-            <a:pPr algn="l">
-              <a:spcAft>
-                <a:spcPts val="600"/>
-              </a:spcAft>
-            </a:pPr>
-            <a:r>
-              <a:rPr sz="1250" b="0" i="0">
-                <a:solidFill>
-                  <a:srgbClr val="CADCFC"/>
-                </a:solidFill>
-                <a:latin typeface="Calibri"/>
-              </a:rPr>
-              <a:t>Age - Medicare  0.61 (eligibility at 65)</a:t>
-            </a:r>
-          </a:p>
-          <a:p>
-            <a:pPr algn="l">
-              <a:spcAft>
-                <a:spcPts val="600"/>
-              </a:spcAft>
-            </a:pPr>
-            <a:r>
-              <a:rPr sz="1250" b="0" i="0">
-                <a:solidFill>
-                  <a:srgbClr val="CADCFC"/>
-                </a:solidFill>
-                <a:latin typeface="Calibri"/>
-              </a:rPr>
-              <a:t>Deaths are rare (28 in ED, 7 DOA in sample), so we compare rates: 6.4% of immediate patients die in the ED.</a:t>
-            </a:r>
-          </a:p>
-        </p:txBody>
-      </p:sp>
-      <p:sp>
-        <p:nvSpPr>
-          <p:cNvPr id="9" name="TextBox 8"/>
+              <a:t>Weighted point estimates without survey-design standard errors.</a:t>
+            </a:r>
+          </a:p>
+        </p:txBody>
+      </p:sp>
+      <p:sp>
+        <p:nvSpPr>
+          <p:cNvPr id="11" name="TextBox 10"/>
           <p:cNvSpPr txBox="1"/>
           <p:nvPr/>
         </p:nvSpPr>
         <p:spPr>
           <a:xfrm>
-            <a:off x="548640" y="5120640"/>
-            <a:ext cx="11064240" cy="1463040"/>
+            <a:off x="548640" y="5230368"/>
+            <a:ext cx="11064240" cy="914400"/>
           </a:xfrm>
           <a:prstGeom prst="rect">
             <a:avLst/>
@@ -8293,13 +7233,13 @@
               </a:spcAft>
             </a:pPr>
             <a:r>
-              <a:rPr sz="1500" b="1" i="0">
+              <a:rPr sz="1500" b="1">
                 <a:solidFill>
                   <a:srgbClr val="FFFFFF"/>
                 </a:solidFill>
                 <a:latin typeface="Calibri"/>
               </a:rPr>
-              <a:t>Takeaways for hospital managers</a:t>
+              <a:t>A question for hospital managers</a:t>
             </a:r>
           </a:p>
           <a:p>
@@ -8309,27 +7249,27 @@
               </a:spcAft>
             </a:pPr>
             <a:r>
-              <a:rPr sz="1350" b="0" i="0">
+              <a:rPr sz="1400" b="0">
                 <a:solidFill>
                   <a:srgbClr val="CADCFC"/>
                 </a:solidFill>
                 <a:latin typeface="Calibri"/>
               </a:rPr>
-              <a:t>Staff to the plateau and Mondays  ·  Fast-track levels 4-5 so emergent patients stop waiting as long as nonurgent ones  ·  Protect margins through Medicaid contracting and payer capture  ·  Invest in chronic-care coordination</a:t>
-            </a:r>
-          </a:p>
-        </p:txBody>
-      </p:sp>
-      <p:sp>
-        <p:nvSpPr>
-          <p:cNvPr id="10" name="TextBox 9"/>
+              <a:t>Emergent (level 2) and nonurgent (level 5) patients have the same recorded median wait, 18 minutes. Do local timestamp data show the same pattern, and if so, where does the delay occur?</a:t>
+            </a:r>
+          </a:p>
+        </p:txBody>
+      </p:sp>
+      <p:sp>
+        <p:nvSpPr>
+          <p:cNvPr id="12" name="TextBox 11"/>
           <p:cNvSpPr txBox="1"/>
           <p:nvPr/>
         </p:nvSpPr>
         <p:spPr>
           <a:xfrm>
-            <a:off x="548640" y="6263640"/>
-            <a:ext cx="11064240" cy="320040"/>
+            <a:off x="548640" y="6355080"/>
+            <a:ext cx="11064240" cy="274320"/>
           </a:xfrm>
           <a:prstGeom prst="rect">
             <a:avLst/>
@@ -8348,13 +7288,13 @@
               </a:spcAft>
             </a:pPr>
             <a:r>
-              <a:rPr sz="1000" b="0" i="0">
+              <a:rPr sz="1000" b="0">
                 <a:solidFill>
                   <a:srgbClr val="CADCFC"/>
                 </a:solidFill>
                 <a:latin typeface="Calibri"/>
               </a:rPr>
-              <a:t>AI use (required by the course): code written with Claude via Claude Code, directed by the group; every result run on the Yale cluster and checked against NCHS figures (20/20); slides drafted with AI from verified outputs.</a:t>
+              <a:t>AI use (course requirement): analysis code and slide drafts produced with an AI coding assistant; every result was run on the Yale cluster and reviewed by the group.</a:t>
             </a:r>
           </a:p>
         </p:txBody>

</xml_diff>

<commit_message>
HW1: final QC pass on write-up and slides
- Q9 paragraph kept on one page; Figure 3 caption trimmed
- Q4 weighted totals (Mon 22.45M vs Sun 18.00M; 8.59M at 6pm) and full Q5 distribution
- Wait-time missingness split: 15.2% blank + 3.4% not applicable = 18.6% no usable wait
- Raw vs capped means distinguished; weighting wording made precise
- Slide 3 title says expected payer; slide 4 reframed on chronic burden and medications
- Visit-level age wording, overlapping medication counts noted, in-hospital deaths
  descriptive only, generic AI-use disclosure in the report

Co-Authored-By: Claude Opus 5.5 <noreply@anthropic.com>
</commit_message>
<xml_diff>
--- a/hw1/report/MGT634_HW1_NHAMCS_slides.pptx
+++ b/hw1/report/MGT634_HW1_NHAMCS_slides.pptx
@@ -5813,7 +5813,7 @@
                 </a:solidFill>
                 <a:latin typeface="Calibri"/>
               </a:rPr>
-              <a:t>Every estimate weighted by PATWT. Missing-value codes recoded before any statistic. Long waits and stays summarized with medians; means reported with values capped at the 99.5th percentile. Key estimates compared with figures NCHS publishes: all agree to rounding except wait-time missingness (15.2% vs 15.7%).</a:t>
+              <a:t>National totals, shares and rates weighted by PATWT; sample counts shown unweighted. Missing-value codes recoded before any statistic. Waits and stays summarized mainly with medians; the write-up also reports raw means and means capped at the 99.5th percentile. Key estimates compared with figures NCHS publishes: all agree to rounding except wait-time missingness (15.2% vs 15.7%).</a:t>
             </a:r>
           </a:p>
         </p:txBody>
@@ -6013,7 +6013,7 @@
                 </a:solidFill>
                 <a:latin typeface="Calibri"/>
               </a:rPr>
-              <a:t>median length of visit (mean 214 min)</a:t>
+              <a:t>median length of visit (raw mean 214 min; 210 with values capped at the 99.5th percentile)</a:t>
             </a:r>
           </a:p>
         </p:txBody>
@@ -6026,7 +6026,7 @@
         </p:nvSpPr>
         <p:spPr>
           <a:xfrm>
-            <a:off x="8595360" y="3246120"/>
+            <a:off x="8595360" y="3520440"/>
             <a:ext cx="3108960" cy="685800"/>
           </a:xfrm>
           <a:prstGeom prst="rect">
@@ -6065,7 +6065,7 @@
         </p:nvSpPr>
         <p:spPr>
           <a:xfrm>
-            <a:off x="8595360" y="3904487"/>
+            <a:off x="8595360" y="4178808"/>
             <a:ext cx="3108960" cy="822960"/>
           </a:xfrm>
           <a:prstGeom prst="rect">
@@ -6104,8 +6104,8 @@
         </p:nvSpPr>
         <p:spPr>
           <a:xfrm>
-            <a:off x="8595360" y="4663440"/>
-            <a:ext cx="3108960" cy="1737360"/>
+            <a:off x="8595360" y="4892040"/>
+            <a:ext cx="3108960" cy="1554480"/>
           </a:xfrm>
           <a:prstGeom prst="rect">
             <a:avLst/>
@@ -6195,7 +6195,7 @@
                 </a:solidFill>
                 <a:latin typeface="Cambria"/>
               </a:rPr>
-              <a:t>Medicaid is the most common expected payer, and age largely determines who pays</a:t>
+              <a:t>Medicaid is the most common expected payer, and the expected payer varies sharply with age</a:t>
             </a:r>
           </a:p>
         </p:txBody>
@@ -6512,7 +6512,7 @@
                 </a:solidFill>
                 <a:latin typeface="Cambria"/>
               </a:rPr>
-              <a:t>Diabetes ranks second among chronic conditions once its three checkboxes are combined</a:t>
+              <a:t>Nearly half of visits involve a chronic condition, and medication use rises with it</a:t>
             </a:r>
           </a:p>
         </p:txBody>
@@ -6604,11 +6604,11 @@
             <a:r>
               <a:rPr sz="3800" b="1">
                 <a:solidFill>
-                  <a:srgbClr val="EB6834"/>
+                  <a:srgbClr val="16324F"/>
                 </a:solidFill>
                 <a:latin typeface="Cambria"/>
               </a:rPr>
-              <a:t>4.7%</a:t>
+              <a:t>47.6%</a:t>
             </a:r>
           </a:p>
         </p:txBody>
@@ -6647,7 +6647,7 @@
                 </a:solidFill>
                 <a:latin typeface="Calibri"/>
               </a:rPr>
-              <a:t>type 2 diabetes alone; combining all three checkboxes gives 11.1%</a:t>
+              <a:t>of visits with the section completed record at least one chronic condition (90% at ages 75+)</a:t>
             </a:r>
           </a:p>
         </p:txBody>
@@ -6660,7 +6660,7 @@
         </p:nvSpPr>
         <p:spPr>
           <a:xfrm>
-            <a:off x="8595360" y="3337560"/>
+            <a:off x="8595360" y="3429000"/>
             <a:ext cx="3108960" cy="685800"/>
           </a:xfrm>
           <a:prstGeom prst="rect">
@@ -6686,7 +6686,7 @@
                 </a:solidFill>
                 <a:latin typeface="Cambria"/>
               </a:rPr>
-              <a:t>47.6%</a:t>
+              <a:t>2.0 → 3.8</a:t>
             </a:r>
           </a:p>
         </p:txBody>
@@ -6699,7 +6699,7 @@
         </p:nvSpPr>
         <p:spPr>
           <a:xfrm>
-            <a:off x="8595360" y="3995928"/>
+            <a:off x="8595360" y="4087368"/>
             <a:ext cx="3108960" cy="822960"/>
           </a:xfrm>
           <a:prstGeom prst="rect">
@@ -6725,7 +6725,7 @@
                 </a:solidFill>
                 <a:latin typeface="Calibri"/>
               </a:rPr>
-              <a:t>record at least one chronic condition (90% at ages 75+)</a:t>
+              <a:t>mean medications per visit: no recorded chronic condition vs three or more</a:t>
             </a:r>
           </a:p>
         </p:txBody>
@@ -6738,8 +6738,8 @@
         </p:nvSpPr>
         <p:spPr>
           <a:xfrm>
-            <a:off x="8595360" y="4754880"/>
-            <a:ext cx="3108960" cy="685800"/>
+            <a:off x="8595360" y="4937760"/>
+            <a:ext cx="3108960" cy="1371600"/>
           </a:xfrm>
           <a:prstGeom prst="rect">
             <a:avLst/>
@@ -6758,52 +6758,13 @@
               </a:spcAft>
             </a:pPr>
             <a:r>
-              <a:rPr sz="3800" b="1">
-                <a:solidFill>
-                  <a:srgbClr val="16324F"/>
-                </a:solidFill>
-                <a:latin typeface="Cambria"/>
-              </a:rPr>
-              <a:t>37.2%</a:t>
-            </a:r>
-          </a:p>
-        </p:txBody>
-      </p:sp>
-      <p:sp>
-        <p:nvSpPr>
-          <p:cNvPr id="10" name="TextBox 9"/>
-          <p:cNvSpPr txBox="1"/>
-          <p:nvPr/>
-        </p:nvSpPr>
-        <p:spPr>
-          <a:xfrm>
-            <a:off x="8595360" y="5413248"/>
-            <a:ext cx="3108960" cy="822960"/>
-          </a:xfrm>
-          <a:prstGeom prst="rect">
-            <a:avLst/>
-          </a:prstGeom>
-          <a:noFill/>
-        </p:spPr>
-        <p:txBody>
-          <a:bodyPr wrap="square" anchor="t" lIns="0" rIns="0" tIns="0" bIns="0">
-            <a:spAutoFit/>
-          </a:bodyPr>
-          <a:lstStyle/>
-          <a:p>
-            <a:pPr algn="l">
-              <a:spcAft>
-                <a:spcPts val="600"/>
-              </a:spcAft>
-            </a:pPr>
-            <a:r>
               <a:rPr sz="1300" b="0">
                 <a:solidFill>
-                  <a:srgbClr val="5A5F66"/>
+                  <a:srgbClr val="1A1A1A"/>
                 </a:solidFill>
                 <a:latin typeface="Calibri"/>
               </a:rPr>
-              <a:t>of all visits involve three or more medications (median 2)</a:t>
+              <a:t>Diabetes is coded in three checkboxes: type 2 alone is 4.7%, but any diabetes (highlighted) is 11.1%, second only to hypertension.</a:t>
             </a:r>
           </a:p>
         </p:txBody>
@@ -7184,7 +7145,7 @@
                 </a:solidFill>
                 <a:latin typeface="Calibri"/>
               </a:rPr>
-              <a:t>15% of visits lack a recorded wait, more often where triage was not recorded and in the Northeast and West.</a:t>
+              <a:t>Wait time is blank for 15.2% of sampled visits and not applicable (not seen by a provider) for 3.4%, so 18.6% have no usable wait; missingness is higher where triage was not recorded and in the Northeast and West.</a:t>
             </a:r>
           </a:p>
           <a:p>

</xml_diff>